<commit_message>
Néerlandais 1: five PowerPoint decks with new colour illustrations
Replace all archive pictures (green pictograms, avatar, photos) with
Fluent Emoji illustrations (MIT), rendered at build time; object glyphs
drawn in colour become illustrations, UI glyphs stay icons. Add the
sound-duration bars and doubling mini-schemas to Module 1, finish
Modules 2–5 (layout fixes, coloured characters Karim, Sofie, Julie),
and document how to regenerate the decks.

Co-Authored-By: Claude Opus 5.5 <noreply@anthropic.com>
Claude-Session: https://claude.ai/code/session_01GHo9GbchfMk8JhTz1kwo92
</commit_message>
<xml_diff>
--- a/neerlandais1/powerpoints/Module_1_Klanken.pptx
+++ b/neerlandais1/powerpoints/Module_1_Klanken.pptx
@@ -132,12 +132,12 @@
   <p:extLst>
     <p:ext uri="{521415D9-36F7-43E2-AB2F-B90AF26B5E84}">
       <p14:sectionLst xmlns:p14="http://schemas.microsoft.com/office/powerpoint/2010/main">
-        <p14:section name="Ouverture" id="{2618b7ef-a5cc-348d-744e-ceb10afc47aa}">
+        <p14:section name="Ouverture" id="{21158495-24cc-6afc-1804-52ea6ea5589a}">
           <p14:sldIdLst>
             <p14:sldId id="256"/>
           </p14:sldIdLst>
         </p14:section>
-        <p14:section name="Découvrir" id="{f483f085-f078-db6e-5503-22ce8281a810}">
+        <p14:section name="Découvrir" id="{59026aba-ef8c-3daf-1d74-0e73483a8afa}">
           <p14:sldIdLst>
             <p14:sldId id="257"/>
             <p14:sldId id="258"/>
@@ -145,7 +145,7 @@
             <p14:sldId id="260"/>
           </p14:sldIdLst>
         </p14:section>
-        <p14:section name="Comprendre" id="{3c042c15-b4ef-1ed5-4326-3feab8154d4f}">
+        <p14:section name="Comprendre" id="{c8f06942-d349-51f8-af0e-d0f280be5ac8}">
           <p14:sldIdLst>
             <p14:sldId id="261"/>
             <p14:sldId id="262"/>
@@ -158,7 +158,7 @@
             <p14:sldId id="269"/>
           </p14:sldIdLst>
         </p14:section>
-        <p14:section name="JIJ NU ! — Oefeningen" id="{78bbc268-0e2a-8c30-e2a6-d607494af7d3}">
+        <p14:section name="JIJ NU ! — Oefeningen" id="{31755027-692d-2116-a3d9-3581e77ed940}">
           <p14:sldIdLst>
             <p14:sldId id="270"/>
             <p14:sldId id="271"/>
@@ -173,7 +173,7 @@
             <p14:sldId id="280"/>
           </p14:sldIdLst>
         </p14:section>
-        <p14:section name="Clôture" id="{f40ef057-7d74-7f2b-8c40-4f0ac73a7965}">
+        <p14:section name="Clôture" id="{74554add-3d52-0642-504c-9389c6a2ab83}">
           <p14:sldIdLst>
             <p14:sldId id="281"/>
           </p14:sldIdLst>
@@ -3872,7 +3872,7 @@
       </p:sp>
       <p:pic>
         <p:nvPicPr>
-          <p:cNvPr id="6" name="Image 0" descr="p_man">    </p:cNvPr>
+          <p:cNvPr id="6" name="Image 0" descr="man">    </p:cNvPr>
           <p:cNvPicPr>
             <a:picLocks noChangeAspect="1"/>
           </p:cNvPicPr>
@@ -3969,7 +3969,7 @@
       </p:sp>
       <p:pic>
         <p:nvPicPr>
-          <p:cNvPr id="9" name="Image 1" descr="Moon">    </p:cNvPr>
+          <p:cNvPr id="9" name="Image 1" descr="crescent moon">    </p:cNvPr>
           <p:cNvPicPr>
             <a:picLocks noChangeAspect="1"/>
           </p:cNvPicPr>
@@ -3983,8 +3983,8 @@
         </p:blipFill>
         <p:spPr>
           <a:xfrm>
-            <a:off x="9875520" y="1920240"/>
-            <a:ext cx="1371600" cy="1371600"/>
+            <a:off x="9738360" y="1920240"/>
+            <a:ext cx="1645920" cy="1645920"/>
           </a:xfrm>
           <a:prstGeom prst="rect">
             <a:avLst/>
@@ -8326,7 +8326,7 @@
       </p:sp>
       <p:pic>
         <p:nvPicPr>
-          <p:cNvPr id="31" name="Image 0" descr="Ban">    </p:cNvPr>
+          <p:cNvPr id="31" name="Image 0" descr="man guard">    </p:cNvPr>
           <p:cNvPicPr>
             <a:picLocks noChangeAspect="1"/>
           </p:cNvPicPr>
@@ -8340,17 +8340,41 @@
         </p:blipFill>
         <p:spPr>
           <a:xfrm>
-            <a:off x="9509760" y="2240280"/>
-            <a:ext cx="1143000" cy="1143000"/>
+            <a:off x="8732520" y="2148840"/>
+            <a:ext cx="1280160" cy="1280160"/>
           </a:xfrm>
           <a:prstGeom prst="rect">
             <a:avLst/>
           </a:prstGeom>
         </p:spPr>
       </p:pic>
-      <p:sp>
-        <p:nvSpPr>
-          <p:cNvPr id="32" name="Text 28"/>
+      <p:pic>
+        <p:nvPicPr>
+          <p:cNvPr id="32" name="Image 1" descr="no entry">    </p:cNvPr>
+          <p:cNvPicPr>
+            <a:picLocks noChangeAspect="1"/>
+          </p:cNvPicPr>
+          <p:nvPr/>
+        </p:nvPicPr>
+        <p:blipFill>
+          <a:blip r:embed="rId2"/>
+          <a:stretch>
+            <a:fillRect/>
+          </a:stretch>
+        </p:blipFill>
+        <p:spPr>
+          <a:xfrm>
+            <a:off x="10195560" y="2331720"/>
+            <a:ext cx="960120" cy="960120"/>
+          </a:xfrm>
+          <a:prstGeom prst="rect">
+            <a:avLst/>
+          </a:prstGeom>
+        </p:spPr>
+      </p:pic>
+      <p:sp>
+        <p:nvSpPr>
+          <p:cNvPr id="33" name="Text 28"/>
           <p:cNvSpPr txBox="1"/>
           <p:nvPr/>
         </p:nvSpPr>
@@ -8411,7 +8435,7 @@
       </p:sp>
       <p:sp>
         <p:nvSpPr>
-          <p:cNvPr id="33" name="Text 29"/>
+          <p:cNvPr id="34" name="Text 29"/>
           <p:cNvSpPr txBox="1"/>
           <p:nvPr/>
         </p:nvSpPr>
@@ -8471,7 +8495,7 @@
       </p:sp>
       <p:sp>
         <p:nvSpPr>
-          <p:cNvPr id="34" name="Shape 30"/>
+          <p:cNvPr id="35" name="Shape 30"/>
           <p:cNvSpPr/>
           <p:nvPr/>
         </p:nvSpPr>
@@ -8500,7 +8524,7 @@
       </p:sp>
       <p:sp>
         <p:nvSpPr>
-          <p:cNvPr id="35" name="Text 31"/>
+          <p:cNvPr id="36" name="Text 31"/>
           <p:cNvSpPr txBox="1"/>
           <p:nvPr/>
         </p:nvSpPr>
@@ -12210,7 +12234,7 @@
       </p:sp>
       <p:pic>
         <p:nvPicPr>
-          <p:cNvPr id="42" name="Image 6" descr="prof_pointe">    </p:cNvPr>
+          <p:cNvPr id="42" name="Image 6" descr="man teacher">    </p:cNvPr>
           <p:cNvPicPr>
             <a:picLocks noChangeAspect="1"/>
           </p:cNvPicPr>
@@ -12224,8 +12248,8 @@
         </p:blipFill>
         <p:spPr>
           <a:xfrm>
-            <a:off x="10058400" y="4480560"/>
-            <a:ext cx="1737360" cy="1737360"/>
+            <a:off x="10058400" y="3657600"/>
+            <a:ext cx="1645920" cy="1645920"/>
           </a:xfrm>
           <a:prstGeom prst="rect">
             <a:avLst/>
@@ -13460,11 +13484,11 @@
         <p:spPr>
           <a:xfrm>
             <a:off x="548640" y="1932432"/>
-            <a:ext cx="2606040" cy="1874520"/>
+            <a:ext cx="2606040" cy="1920240"/>
           </a:xfrm>
           <a:prstGeom prst="roundRect">
             <a:avLst>
-              <a:gd name="adj" fmla="val 3902"/>
+              <a:gd name="adj" fmla="val 3810"/>
             </a:avLst>
           </a:prstGeom>
           <a:solidFill>
@@ -13493,8 +13517,8 @@
         </p:nvSpPr>
         <p:spPr>
           <a:xfrm>
-            <a:off x="548640" y="2069592"/>
-            <a:ext cx="2606040" cy="822960"/>
+            <a:off x="548640" y="1978152"/>
+            <a:ext cx="2606040" cy="640080"/>
           </a:xfrm>
           <a:prstGeom prst="rect">
             <a:avLst/>
@@ -13546,16 +13570,64 @@
           </a:p>
         </p:txBody>
       </p:sp>
-      <p:sp>
-        <p:nvSpPr>
-          <p:cNvPr id="11" name="Text 7"/>
+      <p:pic>
+        <p:nvPicPr>
+          <p:cNvPr id="11" name="Image 1" descr="man">    </p:cNvPr>
+          <p:cNvPicPr>
+            <a:picLocks noChangeAspect="1"/>
+          </p:cNvPicPr>
+          <p:nvPr/>
+        </p:nvPicPr>
+        <p:blipFill>
+          <a:blip r:embed="rId2"/>
+          <a:stretch>
+            <a:fillRect/>
+          </a:stretch>
+        </p:blipFill>
+        <p:spPr>
+          <a:xfrm>
+            <a:off x="960120" y="2645664"/>
+            <a:ext cx="685800" cy="685800"/>
+          </a:xfrm>
+          <a:prstGeom prst="rect">
+            <a:avLst/>
+          </a:prstGeom>
+        </p:spPr>
+      </p:pic>
+      <p:pic>
+        <p:nvPicPr>
+          <p:cNvPr id="12" name="Image 2" descr="crescent moon">    </p:cNvPr>
+          <p:cNvPicPr>
+            <a:picLocks noChangeAspect="1"/>
+          </p:cNvPicPr>
+          <p:nvPr/>
+        </p:nvPicPr>
+        <p:blipFill>
+          <a:blip r:embed="rId3"/>
+          <a:stretch>
+            <a:fillRect/>
+          </a:stretch>
+        </p:blipFill>
+        <p:spPr>
+          <a:xfrm>
+            <a:off x="2057400" y="2645664"/>
+            <a:ext cx="685800" cy="685800"/>
+          </a:xfrm>
+          <a:prstGeom prst="rect">
+            <a:avLst/>
+          </a:prstGeom>
+        </p:spPr>
+      </p:pic>
+      <p:sp>
+        <p:nvSpPr>
+          <p:cNvPr id="13" name="Text 7"/>
           <p:cNvSpPr txBox="1"/>
           <p:nvPr/>
         </p:nvSpPr>
         <p:spPr>
           <a:xfrm>
-            <a:off x="640080" y="2938272"/>
-            <a:ext cx="2423160" cy="731520"/>
+            <a:off x="640080" y="3377184"/>
+            <a:ext cx="2423160" cy="411480"/>
           </a:xfrm>
           <a:prstGeom prst="rect">
             <a:avLst/>
@@ -13571,31 +13643,31 @@
               <a:buNone/>
             </a:pPr>
             <a:r>
-              <a:rPr lang="en-US" sz="1500" i="1" dirty="0">
+              <a:rPr lang="en-US" sz="1400" i="1" dirty="0">
                 <a:solidFill>
                   <a:schemeClr val="accent5"/>
                 </a:solidFill>
               </a:rPr>
               <a:t>homme / lune</a:t>
             </a:r>
-            <a:endParaRPr lang="en-US" sz="1500" dirty="0"/>
-          </a:p>
-        </p:txBody>
-      </p:sp>
-      <p:sp>
-        <p:nvSpPr>
-          <p:cNvPr id="12" name="Shape 8"/>
+            <a:endParaRPr lang="en-US" sz="1400" dirty="0"/>
+          </a:p>
+        </p:txBody>
+      </p:sp>
+      <p:sp>
+        <p:nvSpPr>
+          <p:cNvPr id="14" name="Shape 8"/>
           <p:cNvSpPr/>
           <p:nvPr/>
         </p:nvSpPr>
         <p:spPr>
           <a:xfrm>
             <a:off x="3383280" y="1932432"/>
-            <a:ext cx="2606040" cy="1874520"/>
+            <a:ext cx="2606040" cy="1920240"/>
           </a:xfrm>
           <a:prstGeom prst="roundRect">
             <a:avLst>
-              <a:gd name="adj" fmla="val 3902"/>
+              <a:gd name="adj" fmla="val 3810"/>
             </a:avLst>
           </a:prstGeom>
           <a:solidFill>
@@ -13618,14 +13690,14 @@
       </p:sp>
       <p:sp>
         <p:nvSpPr>
-          <p:cNvPr id="13" name="Text 9"/>
+          <p:cNvPr id="15" name="Text 9"/>
           <p:cNvSpPr txBox="1"/>
           <p:nvPr/>
         </p:nvSpPr>
         <p:spPr>
           <a:xfrm>
-            <a:off x="3383280" y="2069592"/>
-            <a:ext cx="2606040" cy="822960"/>
+            <a:off x="3383280" y="1978152"/>
+            <a:ext cx="2606040" cy="640080"/>
           </a:xfrm>
           <a:prstGeom prst="rect">
             <a:avLst/>
@@ -13677,16 +13749,64 @@
           </a:p>
         </p:txBody>
       </p:sp>
-      <p:sp>
-        <p:nvSpPr>
-          <p:cNvPr id="14" name="Text 10"/>
+      <p:pic>
+        <p:nvPicPr>
+          <p:cNvPr id="16" name="Image 3" descr="herb">    </p:cNvPr>
+          <p:cNvPicPr>
+            <a:picLocks noChangeAspect="1"/>
+          </p:cNvPicPr>
+          <p:nvPr/>
+        </p:nvPicPr>
+        <p:blipFill>
+          <a:blip r:embed="rId4"/>
+          <a:stretch>
+            <a:fillRect/>
+          </a:stretch>
+        </p:blipFill>
+        <p:spPr>
+          <a:xfrm>
+            <a:off x="3794760" y="2645664"/>
+            <a:ext cx="685800" cy="685800"/>
+          </a:xfrm>
+          <a:prstGeom prst="rect">
+            <a:avLst/>
+          </a:prstGeom>
+        </p:spPr>
+      </p:pic>
+      <p:pic>
+        <p:nvPicPr>
+          <p:cNvPr id="17" name="Image 4" descr="clipboard">    </p:cNvPr>
+          <p:cNvPicPr>
+            <a:picLocks noChangeAspect="1"/>
+          </p:cNvPicPr>
+          <p:nvPr/>
+        </p:nvPicPr>
+        <p:blipFill>
+          <a:blip r:embed="rId5"/>
+          <a:stretch>
+            <a:fillRect/>
+          </a:stretch>
+        </p:blipFill>
+        <p:spPr>
+          <a:xfrm>
+            <a:off x="4892040" y="2645664"/>
+            <a:ext cx="685800" cy="685800"/>
+          </a:xfrm>
+          <a:prstGeom prst="rect">
+            <a:avLst/>
+          </a:prstGeom>
+        </p:spPr>
+      </p:pic>
+      <p:sp>
+        <p:nvSpPr>
+          <p:cNvPr id="18" name="Text 10"/>
           <p:cNvSpPr txBox="1"/>
           <p:nvPr/>
         </p:nvSpPr>
         <p:spPr>
           <a:xfrm>
-            <a:off x="3474720" y="2938272"/>
-            <a:ext cx="2423160" cy="731520"/>
+            <a:off x="3474720" y="3377184"/>
+            <a:ext cx="2423160" cy="411480"/>
           </a:xfrm>
           <a:prstGeom prst="rect">
             <a:avLst/>
@@ -13702,31 +13822,31 @@
               <a:buNone/>
             </a:pPr>
             <a:r>
-              <a:rPr lang="en-US" sz="1500" i="1" dirty="0">
+              <a:rPr lang="en-US" sz="1400" i="1" dirty="0">
                 <a:solidFill>
                   <a:schemeClr val="accent5"/>
                 </a:solidFill>
               </a:rPr>
               <a:t>branche / tâche</a:t>
             </a:r>
-            <a:endParaRPr lang="en-US" sz="1500" dirty="0"/>
-          </a:p>
-        </p:txBody>
-      </p:sp>
-      <p:sp>
-        <p:nvSpPr>
-          <p:cNvPr id="15" name="Shape 11"/>
+            <a:endParaRPr lang="en-US" sz="1400" dirty="0"/>
+          </a:p>
+        </p:txBody>
+      </p:sp>
+      <p:sp>
+        <p:nvSpPr>
+          <p:cNvPr id="19" name="Shape 11"/>
           <p:cNvSpPr/>
           <p:nvPr/>
         </p:nvSpPr>
         <p:spPr>
           <a:xfrm>
             <a:off x="6217920" y="1932432"/>
-            <a:ext cx="2606040" cy="1874520"/>
+            <a:ext cx="2606040" cy="1920240"/>
           </a:xfrm>
           <a:prstGeom prst="roundRect">
             <a:avLst>
-              <a:gd name="adj" fmla="val 3902"/>
+              <a:gd name="adj" fmla="val 3810"/>
             </a:avLst>
           </a:prstGeom>
           <a:solidFill>
@@ -13749,14 +13869,14 @@
       </p:sp>
       <p:sp>
         <p:nvSpPr>
-          <p:cNvPr id="16" name="Text 12"/>
+          <p:cNvPr id="20" name="Text 12"/>
           <p:cNvSpPr txBox="1"/>
           <p:nvPr/>
         </p:nvSpPr>
         <p:spPr>
           <a:xfrm>
-            <a:off x="6217920" y="2069592"/>
-            <a:ext cx="2606040" cy="822960"/>
+            <a:off x="6217920" y="1978152"/>
+            <a:ext cx="2606040" cy="640080"/>
           </a:xfrm>
           <a:prstGeom prst="rect">
             <a:avLst/>
@@ -13808,16 +13928,64 @@
           </a:p>
         </p:txBody>
       </p:sp>
-      <p:sp>
-        <p:nvSpPr>
-          <p:cNvPr id="17" name="Text 13"/>
+      <p:pic>
+        <p:nvPicPr>
+          <p:cNvPr id="21" name="Image 5" descr="cityscape">    </p:cNvPr>
+          <p:cNvPicPr>
+            <a:picLocks noChangeAspect="1"/>
+          </p:cNvPicPr>
+          <p:nvPr/>
+        </p:nvPicPr>
+        <p:blipFill>
+          <a:blip r:embed="rId6"/>
+          <a:stretch>
+            <a:fillRect/>
+          </a:stretch>
+        </p:blipFill>
+        <p:spPr>
+          <a:xfrm>
+            <a:off x="6629400" y="2645664"/>
+            <a:ext cx="685800" cy="685800"/>
+          </a:xfrm>
+          <a:prstGeom prst="rect">
+            <a:avLst/>
+          </a:prstGeom>
+        </p:spPr>
+      </p:pic>
+      <p:pic>
+        <p:nvPicPr>
+          <p:cNvPr id="22" name="Image 6" descr="classical building">    </p:cNvPr>
+          <p:cNvPicPr>
+            <a:picLocks noChangeAspect="1"/>
+          </p:cNvPicPr>
+          <p:nvPr/>
+        </p:nvPicPr>
+        <p:blipFill>
+          <a:blip r:embed="rId7"/>
+          <a:stretch>
+            <a:fillRect/>
+          </a:stretch>
+        </p:blipFill>
+        <p:spPr>
+          <a:xfrm>
+            <a:off x="7726680" y="2645664"/>
+            <a:ext cx="685800" cy="685800"/>
+          </a:xfrm>
+          <a:prstGeom prst="rect">
+            <a:avLst/>
+          </a:prstGeom>
+        </p:spPr>
+      </p:pic>
+      <p:sp>
+        <p:nvSpPr>
+          <p:cNvPr id="23" name="Text 13"/>
           <p:cNvSpPr txBox="1"/>
           <p:nvPr/>
         </p:nvSpPr>
         <p:spPr>
           <a:xfrm>
-            <a:off x="6309360" y="2938272"/>
-            <a:ext cx="2423160" cy="731520"/>
+            <a:off x="6309360" y="3377184"/>
+            <a:ext cx="2423160" cy="411480"/>
           </a:xfrm>
           <a:prstGeom prst="rect">
             <a:avLst/>
@@ -13833,31 +14001,31 @@
               <a:buNone/>
             </a:pPr>
             <a:r>
-              <a:rPr lang="en-US" sz="1500" i="1" dirty="0">
+              <a:rPr lang="en-US" sz="1400" i="1" dirty="0">
                 <a:solidFill>
                   <a:schemeClr val="accent5"/>
                 </a:solidFill>
               </a:rPr>
               <a:t>ville / État</a:t>
             </a:r>
-            <a:endParaRPr lang="en-US" sz="1500" dirty="0"/>
-          </a:p>
-        </p:txBody>
-      </p:sp>
-      <p:sp>
-        <p:nvSpPr>
-          <p:cNvPr id="18" name="Shape 14"/>
+            <a:endParaRPr lang="en-US" sz="1400" dirty="0"/>
+          </a:p>
+        </p:txBody>
+      </p:sp>
+      <p:sp>
+        <p:nvSpPr>
+          <p:cNvPr id="24" name="Shape 14"/>
           <p:cNvSpPr/>
           <p:nvPr/>
         </p:nvSpPr>
         <p:spPr>
           <a:xfrm>
             <a:off x="9052560" y="1932432"/>
-            <a:ext cx="2606040" cy="1874520"/>
+            <a:ext cx="2606040" cy="1920240"/>
           </a:xfrm>
           <a:prstGeom prst="roundRect">
             <a:avLst>
-              <a:gd name="adj" fmla="val 3902"/>
+              <a:gd name="adj" fmla="val 3810"/>
             </a:avLst>
           </a:prstGeom>
           <a:solidFill>
@@ -13880,14 +14048,14 @@
       </p:sp>
       <p:sp>
         <p:nvSpPr>
-          <p:cNvPr id="19" name="Text 15"/>
+          <p:cNvPr id="25" name="Text 15"/>
           <p:cNvSpPr txBox="1"/>
           <p:nvPr/>
         </p:nvSpPr>
         <p:spPr>
           <a:xfrm>
-            <a:off x="9052560" y="2069592"/>
-            <a:ext cx="2606040" cy="822960"/>
+            <a:off x="9052560" y="1978152"/>
+            <a:ext cx="2606040" cy="640080"/>
           </a:xfrm>
           <a:prstGeom prst="rect">
             <a:avLst/>
@@ -13939,16 +14107,64 @@
           </a:p>
         </p:txBody>
       </p:sp>
-      <p:sp>
-        <p:nvSpPr>
-          <p:cNvPr id="20" name="Text 16"/>
+      <p:pic>
+        <p:nvPicPr>
+          <p:cNvPr id="26" name="Image 7" descr="balance scale">    </p:cNvPr>
+          <p:cNvPicPr>
+            <a:picLocks noChangeAspect="1"/>
+          </p:cNvPicPr>
+          <p:nvPr/>
+        </p:nvPicPr>
+        <p:blipFill>
+          <a:blip r:embed="rId8"/>
+          <a:stretch>
+            <a:fillRect/>
+          </a:stretch>
+        </p:blipFill>
+        <p:spPr>
+          <a:xfrm>
+            <a:off x="9464040" y="2645664"/>
+            <a:ext cx="685800" cy="685800"/>
+          </a:xfrm>
+          <a:prstGeom prst="rect">
+            <a:avLst/>
+          </a:prstGeom>
+        </p:spPr>
+      </p:pic>
+      <p:pic>
+        <p:nvPicPr>
+          <p:cNvPr id="27" name="Image 8" descr="light bulb">    </p:cNvPr>
+          <p:cNvPicPr>
+            <a:picLocks noChangeAspect="1"/>
+          </p:cNvPicPr>
+          <p:nvPr/>
+        </p:nvPicPr>
+        <p:blipFill>
+          <a:blip r:embed="rId9"/>
+          <a:stretch>
+            <a:fillRect/>
+          </a:stretch>
+        </p:blipFill>
+        <p:spPr>
+          <a:xfrm>
+            <a:off x="10561320" y="2645664"/>
+            <a:ext cx="685800" cy="685800"/>
+          </a:xfrm>
+          <a:prstGeom prst="rect">
+            <a:avLst/>
+          </a:prstGeom>
+        </p:spPr>
+      </p:pic>
+      <p:sp>
+        <p:nvSpPr>
+          <p:cNvPr id="28" name="Text 16"/>
           <p:cNvSpPr txBox="1"/>
           <p:nvPr/>
         </p:nvSpPr>
         <p:spPr>
           <a:xfrm>
-            <a:off x="9144000" y="2938272"/>
-            <a:ext cx="2423160" cy="731520"/>
+            <a:off x="9144000" y="3377184"/>
+            <a:ext cx="2423160" cy="411480"/>
           </a:xfrm>
           <a:prstGeom prst="rect">
             <a:avLst/>
@@ -13964,31 +14180,31 @@
               <a:buNone/>
             </a:pPr>
             <a:r>
-              <a:rPr lang="en-US" sz="1500" i="1" dirty="0">
+              <a:rPr lang="en-US" sz="1400" i="1" dirty="0">
                 <a:solidFill>
                   <a:schemeClr val="accent5"/>
                 </a:solidFill>
               </a:rPr>
               <a:t>loi / je sais</a:t>
             </a:r>
-            <a:endParaRPr lang="en-US" sz="1500" dirty="0"/>
-          </a:p>
-        </p:txBody>
-      </p:sp>
-      <p:sp>
-        <p:nvSpPr>
-          <p:cNvPr id="21" name="Shape 17"/>
+            <a:endParaRPr lang="en-US" sz="1400" dirty="0"/>
+          </a:p>
+        </p:txBody>
+      </p:sp>
+      <p:sp>
+        <p:nvSpPr>
+          <p:cNvPr id="29" name="Shape 17"/>
           <p:cNvSpPr/>
           <p:nvPr/>
         </p:nvSpPr>
         <p:spPr>
           <a:xfrm>
             <a:off x="548640" y="4035552"/>
-            <a:ext cx="2606040" cy="1874520"/>
+            <a:ext cx="2606040" cy="1920240"/>
           </a:xfrm>
           <a:prstGeom prst="roundRect">
             <a:avLst>
-              <a:gd name="adj" fmla="val 3902"/>
+              <a:gd name="adj" fmla="val 3810"/>
             </a:avLst>
           </a:prstGeom>
           <a:solidFill>
@@ -14011,14 +14227,14 @@
       </p:sp>
       <p:sp>
         <p:nvSpPr>
-          <p:cNvPr id="22" name="Text 18"/>
+          <p:cNvPr id="30" name="Text 18"/>
           <p:cNvSpPr txBox="1"/>
           <p:nvPr/>
         </p:nvSpPr>
         <p:spPr>
           <a:xfrm>
-            <a:off x="548640" y="4172712"/>
-            <a:ext cx="2606040" cy="822960"/>
+            <a:off x="548640" y="4081272"/>
+            <a:ext cx="2606040" cy="640080"/>
           </a:xfrm>
           <a:prstGeom prst="rect">
             <a:avLst/>
@@ -14070,16 +14286,64 @@
           </a:p>
         </p:txBody>
       </p:sp>
-      <p:sp>
-        <p:nvSpPr>
-          <p:cNvPr id="23" name="Text 19"/>
+      <p:pic>
+        <p:nvPicPr>
+          <p:cNvPr id="31" name="Image 9" descr="bomb">    </p:cNvPr>
+          <p:cNvPicPr>
+            <a:picLocks noChangeAspect="1"/>
+          </p:cNvPicPr>
+          <p:nvPr/>
+        </p:nvPicPr>
+        <p:blipFill>
+          <a:blip r:embed="rId10"/>
+          <a:stretch>
+            <a:fillRect/>
+          </a:stretch>
+        </p:blipFill>
+        <p:spPr>
+          <a:xfrm>
+            <a:off x="960120" y="4748784"/>
+            <a:ext cx="685800" cy="685800"/>
+          </a:xfrm>
+          <a:prstGeom prst="rect">
+            <a:avLst/>
+          </a:prstGeom>
+        </p:spPr>
+      </p:pic>
+      <p:pic>
+        <p:nvPicPr>
+          <p:cNvPr id="32" name="Image 10" descr="deciduous tree">    </p:cNvPr>
+          <p:cNvPicPr>
+            <a:picLocks noChangeAspect="1"/>
+          </p:cNvPicPr>
+          <p:nvPr/>
+        </p:nvPicPr>
+        <p:blipFill>
+          <a:blip r:embed="rId11"/>
+          <a:stretch>
+            <a:fillRect/>
+          </a:stretch>
+        </p:blipFill>
+        <p:spPr>
+          <a:xfrm>
+            <a:off x="2057400" y="4748784"/>
+            <a:ext cx="685800" cy="685800"/>
+          </a:xfrm>
+          <a:prstGeom prst="rect">
+            <a:avLst/>
+          </a:prstGeom>
+        </p:spPr>
+      </p:pic>
+      <p:sp>
+        <p:nvSpPr>
+          <p:cNvPr id="33" name="Text 19"/>
           <p:cNvSpPr txBox="1"/>
           <p:nvPr/>
         </p:nvSpPr>
         <p:spPr>
           <a:xfrm>
-            <a:off x="640080" y="5041392"/>
-            <a:ext cx="2423160" cy="731520"/>
+            <a:off x="640080" y="5480304"/>
+            <a:ext cx="2423160" cy="411480"/>
           </a:xfrm>
           <a:prstGeom prst="rect">
             <a:avLst/>
@@ -14095,31 +14359,31 @@
               <a:buNone/>
             </a:pPr>
             <a:r>
-              <a:rPr lang="en-US" sz="1500" i="1" dirty="0">
+              <a:rPr lang="en-US" sz="1400" i="1" dirty="0">
                 <a:solidFill>
                   <a:schemeClr val="accent5"/>
                 </a:solidFill>
               </a:rPr>
               <a:t>bombe / arbre</a:t>
             </a:r>
-            <a:endParaRPr lang="en-US" sz="1500" dirty="0"/>
-          </a:p>
-        </p:txBody>
-      </p:sp>
-      <p:sp>
-        <p:nvSpPr>
-          <p:cNvPr id="24" name="Shape 20"/>
+            <a:endParaRPr lang="en-US" sz="1400" dirty="0"/>
+          </a:p>
+        </p:txBody>
+      </p:sp>
+      <p:sp>
+        <p:nvSpPr>
+          <p:cNvPr id="34" name="Shape 20"/>
           <p:cNvSpPr/>
           <p:nvPr/>
         </p:nvSpPr>
         <p:spPr>
           <a:xfrm>
             <a:off x="3383280" y="4035552"/>
-            <a:ext cx="2606040" cy="1874520"/>
+            <a:ext cx="2606040" cy="1920240"/>
           </a:xfrm>
           <a:prstGeom prst="roundRect">
             <a:avLst>
-              <a:gd name="adj" fmla="val 3902"/>
+              <a:gd name="adj" fmla="val 3810"/>
             </a:avLst>
           </a:prstGeom>
           <a:solidFill>
@@ -14142,14 +14406,14 @@
       </p:sp>
       <p:sp>
         <p:nvSpPr>
-          <p:cNvPr id="25" name="Text 21"/>
+          <p:cNvPr id="35" name="Text 21"/>
           <p:cNvSpPr txBox="1"/>
           <p:nvPr/>
         </p:nvSpPr>
         <p:spPr>
           <a:xfrm>
-            <a:off x="3383280" y="4172712"/>
-            <a:ext cx="2606040" cy="822960"/>
+            <a:off x="3383280" y="4081272"/>
+            <a:ext cx="2606040" cy="640080"/>
           </a:xfrm>
           <a:prstGeom prst="rect">
             <a:avLst/>
@@ -14201,16 +14465,64 @@
           </a:p>
         </p:txBody>
       </p:sp>
-      <p:sp>
-        <p:nvSpPr>
-          <p:cNvPr id="26" name="Text 22"/>
+      <p:pic>
+        <p:nvPicPr>
+          <p:cNvPr id="36" name="Image 11" descr="sun">    </p:cNvPr>
+          <p:cNvPicPr>
+            <a:picLocks noChangeAspect="1"/>
+          </p:cNvPicPr>
+          <p:nvPr/>
+        </p:nvPicPr>
+        <p:blipFill>
+          <a:blip r:embed="rId12"/>
+          <a:stretch>
+            <a:fillRect/>
+          </a:stretch>
+        </p:blipFill>
+        <p:spPr>
+          <a:xfrm>
+            <a:off x="3794760" y="4748784"/>
+            <a:ext cx="685800" cy="685800"/>
+          </a:xfrm>
+          <a:prstGeom prst="rect">
+            <a:avLst/>
+          </a:prstGeom>
+        </p:spPr>
+      </p:pic>
+      <p:pic>
+        <p:nvPicPr>
+          <p:cNvPr id="37" name="Image 12" descr="boy">    </p:cNvPr>
+          <p:cNvPicPr>
+            <a:picLocks noChangeAspect="1"/>
+          </p:cNvPicPr>
+          <p:nvPr/>
+        </p:nvPicPr>
+        <p:blipFill>
+          <a:blip r:embed="rId13"/>
+          <a:stretch>
+            <a:fillRect/>
+          </a:stretch>
+        </p:blipFill>
+        <p:spPr>
+          <a:xfrm>
+            <a:off x="4892040" y="4748784"/>
+            <a:ext cx="685800" cy="685800"/>
+          </a:xfrm>
+          <a:prstGeom prst="rect">
+            <a:avLst/>
+          </a:prstGeom>
+        </p:spPr>
+      </p:pic>
+      <p:sp>
+        <p:nvSpPr>
+          <p:cNvPr id="38" name="Text 22"/>
           <p:cNvSpPr txBox="1"/>
           <p:nvPr/>
         </p:nvSpPr>
         <p:spPr>
           <a:xfrm>
-            <a:off x="3474720" y="5041392"/>
-            <a:ext cx="2423160" cy="731520"/>
+            <a:off x="3474720" y="5480304"/>
+            <a:ext cx="2423160" cy="411480"/>
           </a:xfrm>
           <a:prstGeom prst="rect">
             <a:avLst/>
@@ -14226,31 +14538,31 @@
               <a:buNone/>
             </a:pPr>
             <a:r>
-              <a:rPr lang="en-US" sz="1500" i="1" dirty="0">
+              <a:rPr lang="en-US" sz="1400" i="1" dirty="0">
                 <a:solidFill>
                   <a:schemeClr val="accent5"/>
                 </a:solidFill>
               </a:rPr>
               <a:t>soleil / fils</a:t>
             </a:r>
-            <a:endParaRPr lang="en-US" sz="1500" dirty="0"/>
-          </a:p>
-        </p:txBody>
-      </p:sp>
-      <p:sp>
-        <p:nvSpPr>
-          <p:cNvPr id="27" name="Shape 23"/>
+            <a:endParaRPr lang="en-US" sz="1400" dirty="0"/>
+          </a:p>
+        </p:txBody>
+      </p:sp>
+      <p:sp>
+        <p:nvSpPr>
+          <p:cNvPr id="39" name="Shape 23"/>
           <p:cNvSpPr/>
           <p:nvPr/>
         </p:nvSpPr>
         <p:spPr>
           <a:xfrm>
             <a:off x="6217920" y="4035552"/>
-            <a:ext cx="2606040" cy="1874520"/>
+            <a:ext cx="2606040" cy="1920240"/>
           </a:xfrm>
           <a:prstGeom prst="roundRect">
             <a:avLst>
-              <a:gd name="adj" fmla="val 3902"/>
+              <a:gd name="adj" fmla="val 3810"/>
             </a:avLst>
           </a:prstGeom>
           <a:solidFill>
@@ -14273,14 +14585,14 @@
       </p:sp>
       <p:sp>
         <p:nvSpPr>
-          <p:cNvPr id="28" name="Text 24"/>
+          <p:cNvPr id="40" name="Text 24"/>
           <p:cNvSpPr txBox="1"/>
           <p:nvPr/>
         </p:nvSpPr>
         <p:spPr>
           <a:xfrm>
-            <a:off x="6217920" y="4172712"/>
-            <a:ext cx="2606040" cy="822960"/>
+            <a:off x="6217920" y="4081272"/>
+            <a:ext cx="2606040" cy="640080"/>
           </a:xfrm>
           <a:prstGeom prst="rect">
             <a:avLst/>
@@ -14332,16 +14644,64 @@
           </a:p>
         </p:txBody>
       </p:sp>
-      <p:sp>
-        <p:nvSpPr>
-          <p:cNvPr id="29" name="Text 25"/>
+      <p:pic>
+        <p:nvPicPr>
+          <p:cNvPr id="41" name="Image 13" descr="chair">    </p:cNvPr>
+          <p:cNvPicPr>
+            <a:picLocks noChangeAspect="1"/>
+          </p:cNvPicPr>
+          <p:nvPr/>
+        </p:nvPicPr>
+        <p:blipFill>
+          <a:blip r:embed="rId14"/>
+          <a:stretch>
+            <a:fillRect/>
+          </a:stretch>
+        </p:blipFill>
+        <p:spPr>
+          <a:xfrm>
+            <a:off x="6629400" y="4748784"/>
+            <a:ext cx="685800" cy="685800"/>
+          </a:xfrm>
+          <a:prstGeom prst="rect">
+            <a:avLst/>
+          </a:prstGeom>
+        </p:spPr>
+      </p:pic>
+      <p:pic>
+        <p:nvPicPr>
+          <p:cNvPr id="42" name="Image 14" descr="eyes">    </p:cNvPr>
+          <p:cNvPicPr>
+            <a:picLocks noChangeAspect="1"/>
+          </p:cNvPicPr>
+          <p:nvPr/>
+        </p:nvPicPr>
+        <p:blipFill>
+          <a:blip r:embed="rId15"/>
+          <a:stretch>
+            <a:fillRect/>
+          </a:stretch>
+        </p:blipFill>
+        <p:spPr>
+          <a:xfrm>
+            <a:off x="7726680" y="4748784"/>
+            <a:ext cx="685800" cy="685800"/>
+          </a:xfrm>
+          <a:prstGeom prst="rect">
+            <a:avLst/>
+          </a:prstGeom>
+        </p:spPr>
+      </p:pic>
+      <p:sp>
+        <p:nvSpPr>
+          <p:cNvPr id="43" name="Text 25"/>
           <p:cNvSpPr txBox="1"/>
           <p:nvPr/>
         </p:nvSpPr>
         <p:spPr>
           <a:xfrm>
-            <a:off x="6309360" y="5041392"/>
-            <a:ext cx="2423160" cy="731520"/>
+            <a:off x="6309360" y="5480304"/>
+            <a:ext cx="2423160" cy="411480"/>
           </a:xfrm>
           <a:prstGeom prst="rect">
             <a:avLst/>
@@ -14357,31 +14717,31 @@
               <a:buNone/>
             </a:pPr>
             <a:r>
-              <a:rPr lang="en-US" sz="1500" i="1" dirty="0">
+              <a:rPr lang="en-US" sz="1400" i="1" dirty="0">
                 <a:solidFill>
                   <a:schemeClr val="accent5"/>
                 </a:solidFill>
               </a:rPr>
               <a:t>est assis / voit</a:t>
             </a:r>
-            <a:endParaRPr lang="en-US" sz="1500" dirty="0"/>
-          </a:p>
-        </p:txBody>
-      </p:sp>
-      <p:sp>
-        <p:nvSpPr>
-          <p:cNvPr id="30" name="Shape 26"/>
+            <a:endParaRPr lang="en-US" sz="1400" dirty="0"/>
+          </a:p>
+        </p:txBody>
+      </p:sp>
+      <p:sp>
+        <p:nvSpPr>
+          <p:cNvPr id="44" name="Shape 26"/>
           <p:cNvSpPr/>
           <p:nvPr/>
         </p:nvSpPr>
         <p:spPr>
           <a:xfrm>
             <a:off x="9052560" y="4035552"/>
-            <a:ext cx="2606040" cy="1874520"/>
+            <a:ext cx="2606040" cy="1920240"/>
           </a:xfrm>
           <a:prstGeom prst="roundRect">
             <a:avLst>
-              <a:gd name="adj" fmla="val 3902"/>
+              <a:gd name="adj" fmla="val 3810"/>
             </a:avLst>
           </a:prstGeom>
           <a:solidFill>
@@ -14404,14 +14764,14 @@
       </p:sp>
       <p:sp>
         <p:nvSpPr>
-          <p:cNvPr id="31" name="Text 27"/>
+          <p:cNvPr id="45" name="Text 27"/>
           <p:cNvSpPr txBox="1"/>
           <p:nvPr/>
         </p:nvSpPr>
         <p:spPr>
           <a:xfrm>
-            <a:off x="9052560" y="4172712"/>
-            <a:ext cx="2606040" cy="822960"/>
+            <a:off x="9052560" y="4081272"/>
+            <a:ext cx="2606040" cy="640080"/>
           </a:xfrm>
           <a:prstGeom prst="rect">
             <a:avLst/>
@@ -14463,16 +14823,64 @@
           </a:p>
         </p:txBody>
       </p:sp>
-      <p:sp>
-        <p:nvSpPr>
-          <p:cNvPr id="32" name="Text 28"/>
+      <p:pic>
+        <p:nvPicPr>
+          <p:cNvPr id="46" name="Image 15" descr="fountain pen">    </p:cNvPr>
+          <p:cNvPicPr>
+            <a:picLocks noChangeAspect="1"/>
+          </p:cNvPicPr>
+          <p:nvPr/>
+        </p:nvPicPr>
+        <p:blipFill>
+          <a:blip r:embed="rId16"/>
+          <a:stretch>
+            <a:fillRect/>
+          </a:stretch>
+        </p:blipFill>
+        <p:spPr>
+          <a:xfrm>
+            <a:off x="9464040" y="4748784"/>
+            <a:ext cx="685800" cy="685800"/>
+          </a:xfrm>
+          <a:prstGeom prst="rect">
+            <a:avLst/>
+          </a:prstGeom>
+        </p:spPr>
+      </p:pic>
+      <p:pic>
+        <p:nvPicPr>
+          <p:cNvPr id="47" name="Image 16" descr="carrot">    </p:cNvPr>
+          <p:cNvPicPr>
+            <a:picLocks noChangeAspect="1"/>
+          </p:cNvPicPr>
+          <p:nvPr/>
+        </p:nvPicPr>
+        <p:blipFill>
+          <a:blip r:embed="rId17"/>
+          <a:stretch>
+            <a:fillRect/>
+          </a:stretch>
+        </p:blipFill>
+        <p:spPr>
+          <a:xfrm>
+            <a:off x="10561320" y="4748784"/>
+            <a:ext cx="685800" cy="685800"/>
+          </a:xfrm>
+          <a:prstGeom prst="rect">
+            <a:avLst/>
+          </a:prstGeom>
+        </p:spPr>
+      </p:pic>
+      <p:sp>
+        <p:nvSpPr>
+          <p:cNvPr id="48" name="Text 28"/>
           <p:cNvSpPr txBox="1"/>
           <p:nvPr/>
         </p:nvSpPr>
         <p:spPr>
           <a:xfrm>
-            <a:off x="9144000" y="5041392"/>
-            <a:ext cx="2423160" cy="731520"/>
+            <a:off x="9144000" y="5480304"/>
+            <a:ext cx="2423160" cy="411480"/>
           </a:xfrm>
           <a:prstGeom prst="rect">
             <a:avLst/>
@@ -14488,14 +14896,14 @@
               <a:buNone/>
             </a:pPr>
             <a:r>
-              <a:rPr lang="en-US" sz="1500" i="1" dirty="0">
+              <a:rPr lang="en-US" sz="1400" i="1" dirty="0">
                 <a:solidFill>
                   <a:schemeClr val="accent5"/>
                 </a:solidFill>
               </a:rPr>
               <a:t>stylo / carotte</a:t>
             </a:r>
-            <a:endParaRPr lang="en-US" sz="1500" dirty="0"/>
+            <a:endParaRPr lang="en-US" sz="1400" dirty="0"/>
           </a:p>
         </p:txBody>
       </p:sp>
@@ -14811,7 +15219,7 @@
       </p:sp>
       <p:pic>
         <p:nvPicPr>
-          <p:cNvPr id="10" name="Image 1" descr="Scissors">    </p:cNvPr>
+          <p:cNvPr id="10" name="Image 1" descr="scissors">    </p:cNvPr>
           <p:cNvPicPr>
             <a:picLocks noChangeAspect="1"/>
           </p:cNvPicPr>
@@ -14825,8 +15233,8 @@
         </p:blipFill>
         <p:spPr>
           <a:xfrm>
-            <a:off x="2331720" y="1822704"/>
-            <a:ext cx="274320" cy="274320"/>
+            <a:off x="2286000" y="1795272"/>
+            <a:ext cx="347472" cy="347472"/>
           </a:xfrm>
           <a:prstGeom prst="rect">
             <a:avLst/>
@@ -14901,7 +15309,7 @@
       </p:sp>
       <p:pic>
         <p:nvPicPr>
-          <p:cNvPr id="13" name="Image 2" descr="Scissors">    </p:cNvPr>
+          <p:cNvPr id="13" name="Image 2" descr="scissors">    </p:cNvPr>
           <p:cNvPicPr>
             <a:picLocks noChangeAspect="1"/>
           </p:cNvPicPr>
@@ -14915,8 +15323,8 @@
         </p:blipFill>
         <p:spPr>
           <a:xfrm>
-            <a:off x="4599432" y="1822704"/>
-            <a:ext cx="274320" cy="274320"/>
+            <a:off x="4553712" y="1795272"/>
+            <a:ext cx="347472" cy="347472"/>
           </a:xfrm>
           <a:prstGeom prst="rect">
             <a:avLst/>
@@ -14991,7 +15399,7 @@
       </p:sp>
       <p:pic>
         <p:nvPicPr>
-          <p:cNvPr id="16" name="Image 3" descr="Scissors">    </p:cNvPr>
+          <p:cNvPr id="16" name="Image 3" descr="scissors">    </p:cNvPr>
           <p:cNvPicPr>
             <a:picLocks noChangeAspect="1"/>
           </p:cNvPicPr>
@@ -15005,8 +15413,8 @@
         </p:blipFill>
         <p:spPr>
           <a:xfrm>
-            <a:off x="6867144" y="1822704"/>
-            <a:ext cx="274320" cy="274320"/>
+            <a:off x="6821424" y="1795272"/>
+            <a:ext cx="347472" cy="347472"/>
           </a:xfrm>
           <a:prstGeom prst="rect">
             <a:avLst/>
@@ -15081,7 +15489,7 @@
       </p:sp>
       <p:pic>
         <p:nvPicPr>
-          <p:cNvPr id="19" name="Image 4" descr="Scissors">    </p:cNvPr>
+          <p:cNvPr id="19" name="Image 4" descr="scissors">    </p:cNvPr>
           <p:cNvPicPr>
             <a:picLocks noChangeAspect="1"/>
           </p:cNvPicPr>
@@ -15095,8 +15503,8 @@
         </p:blipFill>
         <p:spPr>
           <a:xfrm>
-            <a:off x="9134856" y="1822704"/>
-            <a:ext cx="274320" cy="274320"/>
+            <a:off x="9089136" y="1795272"/>
+            <a:ext cx="347472" cy="347472"/>
           </a:xfrm>
           <a:prstGeom prst="rect">
             <a:avLst/>
@@ -15171,7 +15579,7 @@
       </p:sp>
       <p:pic>
         <p:nvPicPr>
-          <p:cNvPr id="22" name="Image 5" descr="Scissors">    </p:cNvPr>
+          <p:cNvPr id="22" name="Image 5" descr="scissors">    </p:cNvPr>
           <p:cNvPicPr>
             <a:picLocks noChangeAspect="1"/>
           </p:cNvPicPr>
@@ -15185,8 +15593,8 @@
         </p:blipFill>
         <p:spPr>
           <a:xfrm>
-            <a:off x="11402568" y="1822704"/>
-            <a:ext cx="274320" cy="274320"/>
+            <a:off x="11356848" y="1795272"/>
+            <a:ext cx="347472" cy="347472"/>
           </a:xfrm>
           <a:prstGeom prst="rect">
             <a:avLst/>
@@ -15261,7 +15669,7 @@
       </p:sp>
       <p:pic>
         <p:nvPicPr>
-          <p:cNvPr id="25" name="Image 6" descr="Scissors">    </p:cNvPr>
+          <p:cNvPr id="25" name="Image 6" descr="scissors">    </p:cNvPr>
           <p:cNvPicPr>
             <a:picLocks noChangeAspect="1"/>
           </p:cNvPicPr>
@@ -15275,8 +15683,8 @@
         </p:blipFill>
         <p:spPr>
           <a:xfrm>
-            <a:off x="2331720" y="2782824"/>
-            <a:ext cx="274320" cy="274320"/>
+            <a:off x="2286000" y="2755392"/>
+            <a:ext cx="347472" cy="347472"/>
           </a:xfrm>
           <a:prstGeom prst="rect">
             <a:avLst/>
@@ -15351,7 +15759,7 @@
       </p:sp>
       <p:pic>
         <p:nvPicPr>
-          <p:cNvPr id="28" name="Image 7" descr="Scissors">    </p:cNvPr>
+          <p:cNvPr id="28" name="Image 7" descr="scissors">    </p:cNvPr>
           <p:cNvPicPr>
             <a:picLocks noChangeAspect="1"/>
           </p:cNvPicPr>
@@ -15365,8 +15773,8 @@
         </p:blipFill>
         <p:spPr>
           <a:xfrm>
-            <a:off x="4599432" y="2782824"/>
-            <a:ext cx="274320" cy="274320"/>
+            <a:off x="4553712" y="2755392"/>
+            <a:ext cx="347472" cy="347472"/>
           </a:xfrm>
           <a:prstGeom prst="rect">
             <a:avLst/>
@@ -15441,7 +15849,7 @@
       </p:sp>
       <p:pic>
         <p:nvPicPr>
-          <p:cNvPr id="31" name="Image 8" descr="Scissors">    </p:cNvPr>
+          <p:cNvPr id="31" name="Image 8" descr="scissors">    </p:cNvPr>
           <p:cNvPicPr>
             <a:picLocks noChangeAspect="1"/>
           </p:cNvPicPr>
@@ -15455,8 +15863,8 @@
         </p:blipFill>
         <p:spPr>
           <a:xfrm>
-            <a:off x="6867144" y="2782824"/>
-            <a:ext cx="274320" cy="274320"/>
+            <a:off x="6821424" y="2755392"/>
+            <a:ext cx="347472" cy="347472"/>
           </a:xfrm>
           <a:prstGeom prst="rect">
             <a:avLst/>
@@ -15531,7 +15939,7 @@
       </p:sp>
       <p:pic>
         <p:nvPicPr>
-          <p:cNvPr id="34" name="Image 9" descr="Scissors">    </p:cNvPr>
+          <p:cNvPr id="34" name="Image 9" descr="scissors">    </p:cNvPr>
           <p:cNvPicPr>
             <a:picLocks noChangeAspect="1"/>
           </p:cNvPicPr>
@@ -15545,8 +15953,8 @@
         </p:blipFill>
         <p:spPr>
           <a:xfrm>
-            <a:off x="9134856" y="2782824"/>
-            <a:ext cx="274320" cy="274320"/>
+            <a:off x="9089136" y="2755392"/>
+            <a:ext cx="347472" cy="347472"/>
           </a:xfrm>
           <a:prstGeom prst="rect">
             <a:avLst/>
@@ -15621,7 +16029,7 @@
       </p:sp>
       <p:pic>
         <p:nvPicPr>
-          <p:cNvPr id="37" name="Image 10" descr="Scissors">    </p:cNvPr>
+          <p:cNvPr id="37" name="Image 10" descr="scissors">    </p:cNvPr>
           <p:cNvPicPr>
             <a:picLocks noChangeAspect="1"/>
           </p:cNvPicPr>
@@ -15635,8 +16043,8 @@
         </p:blipFill>
         <p:spPr>
           <a:xfrm>
-            <a:off x="11402568" y="2782824"/>
-            <a:ext cx="274320" cy="274320"/>
+            <a:off x="11356848" y="2755392"/>
+            <a:ext cx="347472" cy="347472"/>
           </a:xfrm>
           <a:prstGeom prst="rect">
             <a:avLst/>
@@ -15713,7 +16121,7 @@
       </p:sp>
       <p:pic>
         <p:nvPicPr>
-          <p:cNvPr id="40" name="Image 11" descr="Inbox">    </p:cNvPr>
+          <p:cNvPr id="40" name="Image 11" descr="basket">    </p:cNvPr>
           <p:cNvPicPr>
             <a:picLocks noChangeAspect="1"/>
           </p:cNvPicPr>
@@ -15727,8 +16135,8 @@
         </p:blipFill>
         <p:spPr>
           <a:xfrm>
-            <a:off x="2962656" y="5094732"/>
-            <a:ext cx="640080" cy="640080"/>
+            <a:off x="2825496" y="4957572"/>
+            <a:ext cx="914400" cy="914400"/>
           </a:xfrm>
           <a:prstGeom prst="rect">
             <a:avLst/>
@@ -15805,7 +16213,7 @@
       </p:sp>
       <p:pic>
         <p:nvPicPr>
-          <p:cNvPr id="43" name="Image 12" descr="Inbox">    </p:cNvPr>
+          <p:cNvPr id="43" name="Image 12" descr="basket">    </p:cNvPr>
           <p:cNvPicPr>
             <a:picLocks noChangeAspect="1"/>
           </p:cNvPicPr>
@@ -15819,8 +16227,8 @@
         </p:blipFill>
         <p:spPr>
           <a:xfrm>
-            <a:off x="8586216" y="5094732"/>
-            <a:ext cx="640080" cy="640080"/>
+            <a:off x="8449056" y="4957572"/>
+            <a:ext cx="914400" cy="914400"/>
           </a:xfrm>
           <a:prstGeom prst="rect">
             <a:avLst/>
@@ -17358,7 +17766,7 @@
       </p:sp>
       <p:pic>
         <p:nvPicPr>
-          <p:cNvPr id="20" name="Image 3" descr="Avatar de l’enseignant">    </p:cNvPr>
+          <p:cNvPr id="20" name="Image 3" descr="man teacher">    </p:cNvPr>
           <p:cNvPicPr>
             <a:picLocks noChangeAspect="1"/>
           </p:cNvPicPr>
@@ -17372,17 +17780,41 @@
         </p:blipFill>
         <p:spPr>
           <a:xfrm>
-            <a:off x="9921240" y="3566160"/>
-            <a:ext cx="1920240" cy="1920240"/>
+            <a:off x="9921240" y="1737360"/>
+            <a:ext cx="1737360" cy="1737360"/>
           </a:xfrm>
           <a:prstGeom prst="rect">
             <a:avLst/>
           </a:prstGeom>
         </p:spPr>
       </p:pic>
-      <p:sp>
-        <p:nvSpPr>
-          <p:cNvPr id="21" name="Shape 14"/>
+      <p:pic>
+        <p:nvPicPr>
+          <p:cNvPr id="21" name="Image 4" descr="speech balloon">    </p:cNvPr>
+          <p:cNvPicPr>
+            <a:picLocks noChangeAspect="1"/>
+          </p:cNvPicPr>
+          <p:nvPr/>
+        </p:nvPicPr>
+        <p:blipFill>
+          <a:blip r:embed="rId5"/>
+          <a:stretch>
+            <a:fillRect/>
+          </a:stretch>
+        </p:blipFill>
+        <p:spPr>
+          <a:xfrm>
+            <a:off x="10881360" y="1463040"/>
+            <a:ext cx="731520" cy="731520"/>
+          </a:xfrm>
+          <a:prstGeom prst="rect">
+            <a:avLst/>
+          </a:prstGeom>
+        </p:spPr>
+      </p:pic>
+      <p:sp>
+        <p:nvSpPr>
+          <p:cNvPr id="22" name="Shape 14"/>
           <p:cNvSpPr/>
           <p:nvPr/>
         </p:nvSpPr>
@@ -17409,14 +17841,14 @@
       </p:sp>
       <p:pic>
         <p:nvPicPr>
-          <p:cNvPr id="22" name="Image 4" descr="Lightbulb">    </p:cNvPr>
+          <p:cNvPr id="23" name="Image 5" descr="Lightbulb">    </p:cNvPr>
           <p:cNvPicPr>
             <a:picLocks noChangeAspect="1"/>
           </p:cNvPicPr>
           <p:nvPr/>
         </p:nvPicPr>
         <p:blipFill>
-          <a:blip r:embed="rId5"/>
+          <a:blip r:embed="rId6"/>
           <a:stretch>
             <a:fillRect/>
           </a:stretch>
@@ -17433,7 +17865,7 @@
       </p:pic>
       <p:sp>
         <p:nvSpPr>
-          <p:cNvPr id="23" name="Text 15"/>
+          <p:cNvPr id="24" name="Text 15"/>
           <p:cNvSpPr txBox="1"/>
           <p:nvPr/>
         </p:nvSpPr>
@@ -17719,36 +18151,9 @@
           </a:p>
         </p:txBody>
       </p:sp>
-      <p:sp>
-        <p:nvSpPr>
-          <p:cNvPr id="8" name="Shape 4"/>
-          <p:cNvSpPr/>
-          <p:nvPr/>
-        </p:nvSpPr>
-        <p:spPr>
-          <a:xfrm>
-            <a:off x="548640" y="1978152"/>
-            <a:ext cx="685800" cy="685800"/>
-          </a:xfrm>
-          <a:prstGeom prst="ellipse">
-            <a:avLst/>
-          </a:prstGeom>
-          <a:solidFill>
-            <a:schemeClr val="tx2"/>
-          </a:solidFill>
-          <a:ln w="12700">
-            <a:solidFill>
-              <a:srgbClr val="FFFFFF">
-                <a:alpha val="0"/>
-              </a:srgbClr>
-            </a:solidFill>
-            <a:prstDash val="solid"/>
-          </a:ln>
-        </p:spPr>
-      </p:sp>
       <p:pic>
         <p:nvPicPr>
-          <p:cNvPr id="9" name="Image 1" descr="Factory">    </p:cNvPr>
+          <p:cNvPr id="8" name="Image 1" descr="factory">    </p:cNvPr>
           <p:cNvPicPr>
             <a:picLocks noChangeAspect="1"/>
           </p:cNvPicPr>
@@ -17762,8 +18167,8 @@
         </p:blipFill>
         <p:spPr>
           <a:xfrm>
-            <a:off x="713232" y="2142744"/>
-            <a:ext cx="356616" cy="356616"/>
+            <a:off x="548640" y="1950720"/>
+            <a:ext cx="731520" cy="731520"/>
           </a:xfrm>
           <a:prstGeom prst="rect">
             <a:avLst/>
@@ -17772,7 +18177,7 @@
       </p:pic>
       <p:sp>
         <p:nvSpPr>
-          <p:cNvPr id="10" name="Text 5"/>
+          <p:cNvPr id="9" name="Text 4"/>
           <p:cNvSpPr txBox="1"/>
           <p:nvPr/>
         </p:nvSpPr>
@@ -17808,7 +18213,7 @@
       </p:sp>
       <p:sp>
         <p:nvSpPr>
-          <p:cNvPr id="11" name="Text 6"/>
+          <p:cNvPr id="10" name="Text 5"/>
           <p:cNvSpPr txBox="1"/>
           <p:nvPr/>
         </p:nvSpPr>
@@ -18076,7 +18481,7 @@
       </p:sp>
       <p:sp>
         <p:nvSpPr>
-          <p:cNvPr id="12" name="Text 7"/>
+          <p:cNvPr id="11" name="Text 6"/>
           <p:cNvSpPr txBox="1"/>
           <p:nvPr/>
         </p:nvSpPr>
@@ -18344,7 +18749,7 @@
       </p:sp>
       <p:sp>
         <p:nvSpPr>
-          <p:cNvPr id="13" name="Shape 8"/>
+          <p:cNvPr id="12" name="Shape 7"/>
           <p:cNvSpPr/>
           <p:nvPr/>
         </p:nvSpPr>
@@ -18373,7 +18778,7 @@
       </p:sp>
       <p:sp>
         <p:nvSpPr>
-          <p:cNvPr id="14" name="Text 9"/>
+          <p:cNvPr id="13" name="Text 8"/>
           <p:cNvSpPr txBox="1"/>
           <p:nvPr/>
         </p:nvSpPr>
@@ -18409,7 +18814,7 @@
       </p:sp>
       <p:sp>
         <p:nvSpPr>
-          <p:cNvPr id="15" name="Text 10"/>
+          <p:cNvPr id="14" name="Text 9"/>
           <p:cNvSpPr txBox="1"/>
           <p:nvPr/>
         </p:nvSpPr>
@@ -18845,36 +19250,9 @@
           </a:p>
         </p:txBody>
       </p:sp>
-      <p:sp>
-        <p:nvSpPr>
-          <p:cNvPr id="9" name="Shape 5"/>
-          <p:cNvSpPr/>
-          <p:nvPr/>
-        </p:nvSpPr>
-        <p:spPr>
-          <a:xfrm>
-            <a:off x="548640" y="1978152"/>
-            <a:ext cx="685800" cy="685800"/>
-          </a:xfrm>
-          <a:prstGeom prst="ellipse">
-            <a:avLst/>
-          </a:prstGeom>
-          <a:solidFill>
-            <a:schemeClr val="tx2"/>
-          </a:solidFill>
-          <a:ln w="12700">
-            <a:solidFill>
-              <a:srgbClr val="FFFFFF">
-                <a:alpha val="0"/>
-              </a:srgbClr>
-            </a:solidFill>
-            <a:prstDash val="solid"/>
-          </a:ln>
-        </p:spPr>
-      </p:sp>
       <p:pic>
         <p:nvPicPr>
-          <p:cNvPr id="10" name="Image 1" descr="Factory">    </p:cNvPr>
+          <p:cNvPr id="9" name="Image 1" descr="factory">    </p:cNvPr>
           <p:cNvPicPr>
             <a:picLocks noChangeAspect="1"/>
           </p:cNvPicPr>
@@ -18888,8 +19266,8 @@
         </p:blipFill>
         <p:spPr>
           <a:xfrm>
-            <a:off x="713232" y="2142744"/>
-            <a:ext cx="356616" cy="356616"/>
+            <a:off x="548640" y="1950720"/>
+            <a:ext cx="731520" cy="731520"/>
           </a:xfrm>
           <a:prstGeom prst="rect">
             <a:avLst/>
@@ -18898,7 +19276,7 @@
       </p:pic>
       <p:sp>
         <p:nvSpPr>
-          <p:cNvPr id="11" name="Text 6"/>
+          <p:cNvPr id="10" name="Text 5"/>
           <p:cNvSpPr txBox="1"/>
           <p:nvPr/>
         </p:nvSpPr>
@@ -18934,7 +19312,7 @@
       </p:sp>
       <p:sp>
         <p:nvSpPr>
-          <p:cNvPr id="12" name="Text 7"/>
+          <p:cNvPr id="11" name="Text 6"/>
           <p:cNvSpPr txBox="1"/>
           <p:nvPr/>
         </p:nvSpPr>
@@ -19202,7 +19580,7 @@
       </p:sp>
       <p:sp>
         <p:nvSpPr>
-          <p:cNvPr id="13" name="Text 8"/>
+          <p:cNvPr id="12" name="Text 7"/>
           <p:cNvSpPr txBox="1"/>
           <p:nvPr/>
         </p:nvSpPr>
@@ -19470,7 +19848,7 @@
       </p:sp>
       <p:sp>
         <p:nvSpPr>
-          <p:cNvPr id="14" name="Shape 9"/>
+          <p:cNvPr id="13" name="Shape 8"/>
           <p:cNvSpPr/>
           <p:nvPr/>
         </p:nvSpPr>
@@ -19499,7 +19877,7 @@
       </p:sp>
       <p:sp>
         <p:nvSpPr>
-          <p:cNvPr id="15" name="Text 10"/>
+          <p:cNvPr id="14" name="Text 9"/>
           <p:cNvSpPr txBox="1"/>
           <p:nvPr/>
         </p:nvSpPr>
@@ -19535,7 +19913,7 @@
       </p:sp>
       <p:sp>
         <p:nvSpPr>
-          <p:cNvPr id="16" name="Text 11"/>
+          <p:cNvPr id="15" name="Text 10"/>
           <p:cNvSpPr txBox="1"/>
           <p:nvPr/>
         </p:nvSpPr>
@@ -19933,7 +20311,7 @@
       </p:sp>
       <p:pic>
         <p:nvPicPr>
-          <p:cNvPr id="8" name="Image 1" descr="horloge">    </p:cNvPr>
+          <p:cNvPr id="8" name="Image 1" descr="stopwatch">    </p:cNvPr>
           <p:cNvPicPr>
             <a:picLocks noChangeAspect="1"/>
           </p:cNvPicPr>
@@ -19947,8 +20325,8 @@
         </p:blipFill>
         <p:spPr>
           <a:xfrm>
-            <a:off x="10607040" y="869175"/>
-            <a:ext cx="594360" cy="593369"/>
+            <a:off x="10927080" y="868680"/>
+            <a:ext cx="640080" cy="640080"/>
           </a:xfrm>
           <a:prstGeom prst="rect">
             <a:avLst/>
@@ -21411,7 +21789,7 @@
       </p:sp>
       <p:pic>
         <p:nvPicPr>
-          <p:cNvPr id="9" name="Image 1" descr="horloge">    </p:cNvPr>
+          <p:cNvPr id="9" name="Image 1" descr="stopwatch">    </p:cNvPr>
           <p:cNvPicPr>
             <a:picLocks noChangeAspect="1"/>
           </p:cNvPicPr>
@@ -21425,8 +21803,8 @@
         </p:blipFill>
         <p:spPr>
           <a:xfrm>
-            <a:off x="10607040" y="869175"/>
-            <a:ext cx="594360" cy="593369"/>
+            <a:off x="10927080" y="868680"/>
+            <a:ext cx="640080" cy="640080"/>
           </a:xfrm>
           <a:prstGeom prst="rect">
             <a:avLst/>
@@ -23670,9 +24048,33 @@
           </a:p>
         </p:txBody>
       </p:sp>
-      <p:sp>
-        <p:nvSpPr>
-          <p:cNvPr id="11" name="Shape 7"/>
+      <p:pic>
+        <p:nvPicPr>
+          <p:cNvPr id="11" name="Image 1" descr="cat">    </p:cNvPr>
+          <p:cNvPicPr>
+            <a:picLocks noChangeAspect="1"/>
+          </p:cNvPicPr>
+          <p:nvPr/>
+        </p:nvPicPr>
+        <p:blipFill>
+          <a:blip r:embed="rId2"/>
+          <a:stretch>
+            <a:fillRect/>
+          </a:stretch>
+        </p:blipFill>
+        <p:spPr>
+          <a:xfrm>
+            <a:off x="10607040" y="1709928"/>
+            <a:ext cx="822960" cy="822960"/>
+          </a:xfrm>
+          <a:prstGeom prst="rect">
+            <a:avLst/>
+          </a:prstGeom>
+        </p:spPr>
+      </p:pic>
+      <p:sp>
+        <p:nvSpPr>
+          <p:cNvPr id="12" name="Shape 7"/>
           <p:cNvSpPr/>
           <p:nvPr/>
         </p:nvSpPr>
@@ -23706,7 +24108,7 @@
       </p:sp>
       <p:sp>
         <p:nvSpPr>
-          <p:cNvPr id="12" name="Shape 8"/>
+          <p:cNvPr id="13" name="Shape 8"/>
           <p:cNvSpPr/>
           <p:nvPr/>
         </p:nvSpPr>
@@ -23733,14 +24135,14 @@
       </p:sp>
       <p:pic>
         <p:nvPicPr>
-          <p:cNvPr id="13" name="Image 1" descr="Microphone">    </p:cNvPr>
+          <p:cNvPr id="14" name="Image 2" descr="Microphone">    </p:cNvPr>
           <p:cNvPicPr>
             <a:picLocks noChangeAspect="1"/>
           </p:cNvPicPr>
           <p:nvPr/>
         </p:nvPicPr>
         <p:blipFill>
-          <a:blip r:embed="rId2"/>
+          <a:blip r:embed="rId3"/>
           <a:stretch>
             <a:fillRect/>
           </a:stretch>
@@ -23757,7 +24159,7 @@
       </p:pic>
       <p:sp>
         <p:nvSpPr>
-          <p:cNvPr id="14" name="Text 9"/>
+          <p:cNvPr id="15" name="Text 9"/>
           <p:cNvSpPr txBox="1"/>
           <p:nvPr/>
         </p:nvSpPr>
@@ -23862,7 +24264,7 @@
       </p:sp>
       <p:sp>
         <p:nvSpPr>
-          <p:cNvPr id="15" name="Text 10"/>
+          <p:cNvPr id="16" name="Text 10"/>
           <p:cNvSpPr txBox="1"/>
           <p:nvPr/>
         </p:nvSpPr>
@@ -23896,9 +24298,33 @@
           </a:p>
         </p:txBody>
       </p:sp>
-      <p:sp>
-        <p:nvSpPr>
-          <p:cNvPr id="16" name="Shape 11"/>
+      <p:pic>
+        <p:nvPicPr>
+          <p:cNvPr id="17" name="Image 3" descr="sun behind cloud">    </p:cNvPr>
+          <p:cNvPicPr>
+            <a:picLocks noChangeAspect="1"/>
+          </p:cNvPicPr>
+          <p:nvPr/>
+        </p:nvPicPr>
+        <p:blipFill>
+          <a:blip r:embed="rId4"/>
+          <a:stretch>
+            <a:fillRect/>
+          </a:stretch>
+        </p:blipFill>
+        <p:spPr>
+          <a:xfrm>
+            <a:off x="10607040" y="3008376"/>
+            <a:ext cx="822960" cy="822960"/>
+          </a:xfrm>
+          <a:prstGeom prst="rect">
+            <a:avLst/>
+          </a:prstGeom>
+        </p:spPr>
+      </p:pic>
+      <p:sp>
+        <p:nvSpPr>
+          <p:cNvPr id="18" name="Shape 11"/>
           <p:cNvSpPr/>
           <p:nvPr/>
         </p:nvSpPr>
@@ -23932,7 +24358,7 @@
       </p:sp>
       <p:sp>
         <p:nvSpPr>
-          <p:cNvPr id="17" name="Shape 12"/>
+          <p:cNvPr id="19" name="Shape 12"/>
           <p:cNvSpPr/>
           <p:nvPr/>
         </p:nvSpPr>
@@ -23959,14 +24385,14 @@
       </p:sp>
       <p:pic>
         <p:nvPicPr>
-          <p:cNvPr id="18" name="Image 2" descr="Microphone">    </p:cNvPr>
+          <p:cNvPr id="20" name="Image 4" descr="Microphone">    </p:cNvPr>
           <p:cNvPicPr>
             <a:picLocks noChangeAspect="1"/>
           </p:cNvPicPr>
           <p:nvPr/>
         </p:nvPicPr>
         <p:blipFill>
-          <a:blip r:embed="rId3"/>
+          <a:blip r:embed="rId5"/>
           <a:stretch>
             <a:fillRect/>
           </a:stretch>
@@ -23983,7 +24409,7 @@
       </p:pic>
       <p:sp>
         <p:nvSpPr>
-          <p:cNvPr id="19" name="Text 13"/>
+          <p:cNvPr id="21" name="Text 13"/>
           <p:cNvSpPr txBox="1"/>
           <p:nvPr/>
         </p:nvSpPr>
@@ -24088,7 +24514,7 @@
       </p:sp>
       <p:sp>
         <p:nvSpPr>
-          <p:cNvPr id="20" name="Text 14"/>
+          <p:cNvPr id="22" name="Text 14"/>
           <p:cNvSpPr txBox="1"/>
           <p:nvPr/>
         </p:nvSpPr>
@@ -24122,9 +24548,33 @@
           </a:p>
         </p:txBody>
       </p:sp>
-      <p:sp>
-        <p:nvSpPr>
-          <p:cNvPr id="21" name="Text 15"/>
+      <p:pic>
+        <p:nvPicPr>
+          <p:cNvPr id="23" name="Image 5" descr="balance scale">    </p:cNvPr>
+          <p:cNvPicPr>
+            <a:picLocks noChangeAspect="1"/>
+          </p:cNvPicPr>
+          <p:nvPr/>
+        </p:nvPicPr>
+        <p:blipFill>
+          <a:blip r:embed="rId6"/>
+          <a:stretch>
+            <a:fillRect/>
+          </a:stretch>
+        </p:blipFill>
+        <p:spPr>
+          <a:xfrm>
+            <a:off x="10607040" y="4306824"/>
+            <a:ext cx="822960" cy="822960"/>
+          </a:xfrm>
+          <a:prstGeom prst="rect">
+            <a:avLst/>
+          </a:prstGeom>
+        </p:spPr>
+      </p:pic>
+      <p:sp>
+        <p:nvSpPr>
+          <p:cNvPr id="24" name="Text 15"/>
           <p:cNvSpPr txBox="1"/>
           <p:nvPr/>
         </p:nvSpPr>
@@ -24160,7 +24610,7 @@
       </p:sp>
       <p:sp>
         <p:nvSpPr>
-          <p:cNvPr id="22" name="Text 16"/>
+          <p:cNvPr id="25" name="Text 16"/>
           <p:cNvSpPr txBox="1"/>
           <p:nvPr/>
         </p:nvSpPr>
@@ -28521,7 +28971,7 @@
       </p:sp>
       <p:pic>
         <p:nvPicPr>
-          <p:cNvPr id="10" name="Image 0" descr="p_man">    </p:cNvPr>
+          <p:cNvPr id="10" name="Image 0" descr="man">    </p:cNvPr>
           <p:cNvPicPr>
             <a:picLocks noChangeAspect="1"/>
           </p:cNvPicPr>
@@ -28535,8 +28985,8 @@
         </p:blipFill>
         <p:spPr>
           <a:xfrm>
-            <a:off x="1732788" y="1627632"/>
-            <a:ext cx="731520" cy="731520"/>
+            <a:off x="1737360" y="1645920"/>
+            <a:ext cx="694944" cy="694944"/>
           </a:xfrm>
           <a:prstGeom prst="rect">
             <a:avLst/>
@@ -28647,7 +29097,7 @@
       </p:sp>
       <p:pic>
         <p:nvPicPr>
-          <p:cNvPr id="14" name="Image 1" descr="p_slaan">    </p:cNvPr>
+          <p:cNvPr id="14" name="Image 1" descr="oncoming fist">    </p:cNvPr>
           <p:cNvPicPr>
             <a:picLocks noChangeAspect="1"/>
           </p:cNvPicPr>
@@ -28661,8 +29111,8 @@
         </p:blipFill>
         <p:spPr>
           <a:xfrm>
-            <a:off x="6487668" y="1627632"/>
-            <a:ext cx="731520" cy="731520"/>
+            <a:off x="6492240" y="1645920"/>
+            <a:ext cx="694944" cy="694944"/>
           </a:xfrm>
           <a:prstGeom prst="rect">
             <a:avLst/>
@@ -28908,7 +29358,7 @@
       </p:sp>
       <p:pic>
         <p:nvPicPr>
-          <p:cNvPr id="23" name="Image 3" descr="p_fles">    </p:cNvPr>
+          <p:cNvPr id="23" name="Image 3" descr="bottle with popping cork">    </p:cNvPr>
           <p:cNvPicPr>
             <a:picLocks noChangeAspect="1"/>
           </p:cNvPicPr>
@@ -28922,8 +29372,8 @@
         </p:blipFill>
         <p:spPr>
           <a:xfrm>
-            <a:off x="1732788" y="2578608"/>
-            <a:ext cx="731520" cy="731520"/>
+            <a:off x="1737360" y="2596896"/>
+            <a:ext cx="694944" cy="694944"/>
           </a:xfrm>
           <a:prstGeom prst="rect">
             <a:avLst/>
@@ -29034,7 +29484,7 @@
       </p:sp>
       <p:pic>
         <p:nvPicPr>
-          <p:cNvPr id="27" name="Image 4" descr="p_lezen">    </p:cNvPr>
+          <p:cNvPr id="27" name="Image 4" descr="open book">    </p:cNvPr>
           <p:cNvPicPr>
             <a:picLocks noChangeAspect="1"/>
           </p:cNvPicPr>
@@ -29048,8 +29498,8 @@
         </p:blipFill>
         <p:spPr>
           <a:xfrm>
-            <a:off x="6487668" y="2578608"/>
-            <a:ext cx="731520" cy="731520"/>
+            <a:off x="6492240" y="2596896"/>
+            <a:ext cx="694944" cy="694944"/>
           </a:xfrm>
           <a:prstGeom prst="rect">
             <a:avLst/>
@@ -29295,7 +29745,7 @@
       </p:sp>
       <p:pic>
         <p:nvPicPr>
-          <p:cNvPr id="36" name="Image 6" descr="Chair">    </p:cNvPr>
+          <p:cNvPr id="36" name="Image 6" descr="chair">    </p:cNvPr>
           <p:cNvPicPr>
             <a:picLocks noChangeAspect="1"/>
           </p:cNvPicPr>
@@ -29309,8 +29759,8 @@
         </p:blipFill>
         <p:spPr>
           <a:xfrm>
-            <a:off x="1783080" y="3575304"/>
-            <a:ext cx="640080" cy="640080"/>
+            <a:off x="1737360" y="3547872"/>
+            <a:ext cx="694944" cy="694944"/>
           </a:xfrm>
           <a:prstGeom prst="rect">
             <a:avLst/>
@@ -29421,7 +29871,7 @@
       </p:sp>
       <p:pic>
         <p:nvPicPr>
-          <p:cNvPr id="40" name="Image 7" descr="Eye">    </p:cNvPr>
+          <p:cNvPr id="40" name="Image 7" descr="eyes">    </p:cNvPr>
           <p:cNvPicPr>
             <a:picLocks noChangeAspect="1"/>
           </p:cNvPicPr>
@@ -29435,8 +29885,8 @@
         </p:blipFill>
         <p:spPr>
           <a:xfrm>
-            <a:off x="6537960" y="3575304"/>
-            <a:ext cx="640080" cy="640080"/>
+            <a:off x="6492240" y="3547872"/>
+            <a:ext cx="694944" cy="694944"/>
           </a:xfrm>
           <a:prstGeom prst="rect">
             <a:avLst/>
@@ -29682,7 +30132,7 @@
       </p:sp>
       <p:pic>
         <p:nvPicPr>
-          <p:cNvPr id="49" name="Image 9" descr="p_koppel">    </p:cNvPr>
+          <p:cNvPr id="49" name="Image 9" descr="two hearts">    </p:cNvPr>
           <p:cNvPicPr>
             <a:picLocks noChangeAspect="1"/>
           </p:cNvPicPr>
@@ -29696,8 +30146,8 @@
         </p:blipFill>
         <p:spPr>
           <a:xfrm>
-            <a:off x="1732788" y="4480560"/>
-            <a:ext cx="731520" cy="731520"/>
+            <a:off x="1737360" y="4498848"/>
+            <a:ext cx="694944" cy="694944"/>
           </a:xfrm>
           <a:prstGeom prst="rect">
             <a:avLst/>
@@ -29808,7 +30258,7 @@
       </p:sp>
       <p:pic>
         <p:nvPicPr>
-          <p:cNvPr id="53" name="Image 10" descr="p_lopen">    </p:cNvPr>
+          <p:cNvPr id="53" name="Image 10" descr="person walking">    </p:cNvPr>
           <p:cNvPicPr>
             <a:picLocks noChangeAspect="1"/>
           </p:cNvPicPr>
@@ -29822,8 +30272,8 @@
         </p:blipFill>
         <p:spPr>
           <a:xfrm>
-            <a:off x="6487668" y="4480560"/>
-            <a:ext cx="731520" cy="731520"/>
+            <a:off x="6492240" y="4498848"/>
+            <a:ext cx="694944" cy="694944"/>
           </a:xfrm>
           <a:prstGeom prst="rect">
             <a:avLst/>
@@ -30069,7 +30519,7 @@
       </p:sp>
       <p:pic>
         <p:nvPicPr>
-          <p:cNvPr id="62" name="Image 12" descr="p_kus">    </p:cNvPr>
+          <p:cNvPr id="62" name="Image 12" descr="kiss mark">    </p:cNvPr>
           <p:cNvPicPr>
             <a:picLocks noChangeAspect="1"/>
           </p:cNvPicPr>
@@ -30083,8 +30533,8 @@
         </p:blipFill>
         <p:spPr>
           <a:xfrm>
-            <a:off x="1732788" y="5431536"/>
-            <a:ext cx="731520" cy="731520"/>
+            <a:off x="1737360" y="5449824"/>
+            <a:ext cx="694944" cy="694944"/>
           </a:xfrm>
           <a:prstGeom prst="rect">
             <a:avLst/>
@@ -30195,7 +30645,7 @@
       </p:sp>
       <p:pic>
         <p:nvPicPr>
-          <p:cNvPr id="66" name="Image 13" descr="p_vuur">    </p:cNvPr>
+          <p:cNvPr id="66" name="Image 13" descr="fire">    </p:cNvPr>
           <p:cNvPicPr>
             <a:picLocks noChangeAspect="1"/>
           </p:cNvPicPr>
@@ -30209,8 +30659,8 @@
         </p:blipFill>
         <p:spPr>
           <a:xfrm>
-            <a:off x="6487668" y="5431536"/>
-            <a:ext cx="731520" cy="731520"/>
+            <a:off x="6492240" y="5449824"/>
+            <a:ext cx="694944" cy="694944"/>
           </a:xfrm>
           <a:prstGeom prst="rect">
             <a:avLst/>
@@ -30644,7 +31094,7 @@
       </p:sp>
       <p:pic>
         <p:nvPicPr>
-          <p:cNvPr id="11" name="Image 0" descr="p_man">    </p:cNvPr>
+          <p:cNvPr id="11" name="Image 0" descr="man">    </p:cNvPr>
           <p:cNvPicPr>
             <a:picLocks noChangeAspect="1"/>
           </p:cNvPicPr>
@@ -30658,8 +31108,8 @@
         </p:blipFill>
         <p:spPr>
           <a:xfrm>
-            <a:off x="1732788" y="1627632"/>
-            <a:ext cx="731520" cy="731520"/>
+            <a:off x="1737360" y="1645920"/>
+            <a:ext cx="694944" cy="694944"/>
           </a:xfrm>
           <a:prstGeom prst="rect">
             <a:avLst/>
@@ -30675,7 +31125,7 @@
         <p:spPr>
           <a:xfrm>
             <a:off x="2651760" y="1572768"/>
-            <a:ext cx="1645920" cy="841248"/>
+            <a:ext cx="1645920" cy="566928"/>
           </a:xfrm>
           <a:prstGeom prst="rect">
             <a:avLst/>
@@ -30707,7 +31157,36 @@
       </p:sp>
       <p:sp>
         <p:nvSpPr>
-          <p:cNvPr id="13" name="Text 9"/>
+          <p:cNvPr id="13" name="Shape 9"/>
+          <p:cNvSpPr/>
+          <p:nvPr/>
+        </p:nvSpPr>
+        <p:spPr>
+          <a:xfrm>
+            <a:off x="2679192" y="2176272"/>
+            <a:ext cx="411480" cy="100584"/>
+          </a:xfrm>
+          <a:prstGeom prst="roundRect">
+            <a:avLst>
+              <a:gd name="adj" fmla="val 45455"/>
+            </a:avLst>
+          </a:prstGeom>
+          <a:solidFill>
+            <a:schemeClr val="accent4"/>
+          </a:solidFill>
+          <a:ln w="12700">
+            <a:solidFill>
+              <a:srgbClr val="FFFFFF">
+                <a:alpha val="0"/>
+              </a:srgbClr>
+            </a:solidFill>
+            <a:prstDash val="solid"/>
+          </a:ln>
+        </p:spPr>
+      </p:sp>
+      <p:sp>
+        <p:nvSpPr>
+          <p:cNvPr id="14" name="Text 10"/>
           <p:cNvSpPr txBox="1"/>
           <p:nvPr/>
         </p:nvSpPr>
@@ -30743,7 +31222,7 @@
       </p:sp>
       <p:sp>
         <p:nvSpPr>
-          <p:cNvPr id="14" name="tag"/>
+          <p:cNvPr id="15" name="tag"/>
           <p:cNvSpPr/>
           <p:nvPr/>
         </p:nvSpPr>
@@ -30783,7 +31262,7 @@
       </p:sp>
       <p:sp>
         <p:nvSpPr>
-          <p:cNvPr id="15" name="Shape 11"/>
+          <p:cNvPr id="16" name="Shape 12"/>
           <p:cNvSpPr/>
           <p:nvPr/>
         </p:nvSpPr>
@@ -30810,7 +31289,7 @@
       </p:sp>
       <p:pic>
         <p:nvPicPr>
-          <p:cNvPr id="16" name="Image 1" descr="p_slaan">    </p:cNvPr>
+          <p:cNvPr id="17" name="Image 1" descr="oncoming fist">    </p:cNvPr>
           <p:cNvPicPr>
             <a:picLocks noChangeAspect="1"/>
           </p:cNvPicPr>
@@ -30824,8 +31303,8 @@
         </p:blipFill>
         <p:spPr>
           <a:xfrm>
-            <a:off x="6487668" y="1627632"/>
-            <a:ext cx="731520" cy="731520"/>
+            <a:off x="6492240" y="1645920"/>
+            <a:ext cx="694944" cy="694944"/>
           </a:xfrm>
           <a:prstGeom prst="rect">
             <a:avLst/>
@@ -30834,14 +31313,14 @@
       </p:pic>
       <p:sp>
         <p:nvSpPr>
-          <p:cNvPr id="17" name="Text 12"/>
+          <p:cNvPr id="18" name="Text 13"/>
           <p:cNvSpPr txBox="1"/>
           <p:nvPr/>
         </p:nvSpPr>
         <p:spPr>
           <a:xfrm>
             <a:off x="7406640" y="1572768"/>
-            <a:ext cx="1645920" cy="841248"/>
+            <a:ext cx="1645920" cy="566928"/>
           </a:xfrm>
           <a:prstGeom prst="rect">
             <a:avLst/>
@@ -30873,7 +31352,36 @@
       </p:sp>
       <p:sp>
         <p:nvSpPr>
-          <p:cNvPr id="18" name="Text 13"/>
+          <p:cNvPr id="19" name="Shape 14"/>
+          <p:cNvSpPr/>
+          <p:nvPr/>
+        </p:nvSpPr>
+        <p:spPr>
+          <a:xfrm>
+            <a:off x="7434072" y="2176272"/>
+            <a:ext cx="1463040" cy="100584"/>
+          </a:xfrm>
+          <a:prstGeom prst="roundRect">
+            <a:avLst>
+              <a:gd name="adj" fmla="val 45455"/>
+            </a:avLst>
+          </a:prstGeom>
+          <a:solidFill>
+            <a:schemeClr val="accent3"/>
+          </a:solidFill>
+          <a:ln w="12700">
+            <a:solidFill>
+              <a:srgbClr val="FFFFFF">
+                <a:alpha val="0"/>
+              </a:srgbClr>
+            </a:solidFill>
+            <a:prstDash val="solid"/>
+          </a:ln>
+        </p:spPr>
+      </p:sp>
+      <p:sp>
+        <p:nvSpPr>
+          <p:cNvPr id="20" name="Text 15"/>
           <p:cNvSpPr txBox="1"/>
           <p:nvPr/>
         </p:nvSpPr>
@@ -30909,7 +31417,7 @@
       </p:sp>
       <p:sp>
         <p:nvSpPr>
-          <p:cNvPr id="19" name="tag"/>
+          <p:cNvPr id="21" name="tag"/>
           <p:cNvSpPr/>
           <p:nvPr/>
         </p:nvSpPr>
@@ -30949,7 +31457,7 @@
       </p:sp>
       <p:pic>
         <p:nvPicPr>
-          <p:cNvPr id="20" name="Image 2" descr="VolumeUp">    </p:cNvPr>
+          <p:cNvPr id="22" name="Image 2" descr="VolumeUp">    </p:cNvPr>
           <p:cNvPicPr>
             <a:picLocks noChangeAspect="1"/>
           </p:cNvPicPr>
@@ -30973,7 +31481,7 @@
       </p:pic>
       <p:sp>
         <p:nvSpPr>
-          <p:cNvPr id="21" name="Shape 15"/>
+          <p:cNvPr id="23" name="Shape 17"/>
           <p:cNvSpPr/>
           <p:nvPr/>
         </p:nvSpPr>
@@ -31000,7 +31508,7 @@
       </p:sp>
       <p:sp>
         <p:nvSpPr>
-          <p:cNvPr id="22" name="Text 16"/>
+          <p:cNvPr id="24" name="Text 18"/>
           <p:cNvSpPr txBox="1"/>
           <p:nvPr/>
         </p:nvSpPr>
@@ -31036,7 +31544,7 @@
       </p:sp>
       <p:sp>
         <p:nvSpPr>
-          <p:cNvPr id="23" name="Shape 17"/>
+          <p:cNvPr id="25" name="Shape 19"/>
           <p:cNvSpPr/>
           <p:nvPr/>
         </p:nvSpPr>
@@ -31060,7 +31568,7 @@
       </p:sp>
       <p:sp>
         <p:nvSpPr>
-          <p:cNvPr id="24" name="Shape 18"/>
+          <p:cNvPr id="26" name="Shape 20"/>
           <p:cNvSpPr/>
           <p:nvPr/>
         </p:nvSpPr>
@@ -31084,7 +31592,7 @@
       </p:sp>
       <p:sp>
         <p:nvSpPr>
-          <p:cNvPr id="25" name="Shape 19"/>
+          <p:cNvPr id="27" name="Shape 21"/>
           <p:cNvSpPr/>
           <p:nvPr/>
         </p:nvSpPr>
@@ -31111,7 +31619,7 @@
       </p:sp>
       <p:pic>
         <p:nvPicPr>
-          <p:cNvPr id="26" name="Image 3" descr="p_fles">    </p:cNvPr>
+          <p:cNvPr id="28" name="Image 3" descr="bottle with popping cork">    </p:cNvPr>
           <p:cNvPicPr>
             <a:picLocks noChangeAspect="1"/>
           </p:cNvPicPr>
@@ -31125,8 +31633,8 @@
         </p:blipFill>
         <p:spPr>
           <a:xfrm>
-            <a:off x="1732788" y="2578608"/>
-            <a:ext cx="731520" cy="731520"/>
+            <a:off x="1737360" y="2596896"/>
+            <a:ext cx="694944" cy="694944"/>
           </a:xfrm>
           <a:prstGeom prst="rect">
             <a:avLst/>
@@ -31135,14 +31643,14 @@
       </p:pic>
       <p:sp>
         <p:nvSpPr>
-          <p:cNvPr id="27" name="Text 20"/>
+          <p:cNvPr id="29" name="Text 22"/>
           <p:cNvSpPr txBox="1"/>
           <p:nvPr/>
         </p:nvSpPr>
         <p:spPr>
           <a:xfrm>
             <a:off x="2651760" y="2523744"/>
-            <a:ext cx="1645920" cy="841248"/>
+            <a:ext cx="1645920" cy="566928"/>
           </a:xfrm>
           <a:prstGeom prst="rect">
             <a:avLst/>
@@ -31174,7 +31682,36 @@
       </p:sp>
       <p:sp>
         <p:nvSpPr>
-          <p:cNvPr id="28" name="Text 21"/>
+          <p:cNvPr id="30" name="Shape 23"/>
+          <p:cNvSpPr/>
+          <p:nvPr/>
+        </p:nvSpPr>
+        <p:spPr>
+          <a:xfrm>
+            <a:off x="2679192" y="3127248"/>
+            <a:ext cx="411480" cy="100584"/>
+          </a:xfrm>
+          <a:prstGeom prst="roundRect">
+            <a:avLst>
+              <a:gd name="adj" fmla="val 45455"/>
+            </a:avLst>
+          </a:prstGeom>
+          <a:solidFill>
+            <a:schemeClr val="accent4"/>
+          </a:solidFill>
+          <a:ln w="12700">
+            <a:solidFill>
+              <a:srgbClr val="FFFFFF">
+                <a:alpha val="0"/>
+              </a:srgbClr>
+            </a:solidFill>
+            <a:prstDash val="solid"/>
+          </a:ln>
+        </p:spPr>
+      </p:sp>
+      <p:sp>
+        <p:nvSpPr>
+          <p:cNvPr id="31" name="Text 24"/>
           <p:cNvSpPr txBox="1"/>
           <p:nvPr/>
         </p:nvSpPr>
@@ -31210,7 +31747,7 @@
       </p:sp>
       <p:sp>
         <p:nvSpPr>
-          <p:cNvPr id="29" name="tag"/>
+          <p:cNvPr id="32" name="tag"/>
           <p:cNvSpPr/>
           <p:nvPr/>
         </p:nvSpPr>
@@ -31250,7 +31787,7 @@
       </p:sp>
       <p:sp>
         <p:nvSpPr>
-          <p:cNvPr id="30" name="Shape 23"/>
+          <p:cNvPr id="33" name="Shape 26"/>
           <p:cNvSpPr/>
           <p:nvPr/>
         </p:nvSpPr>
@@ -31277,7 +31814,7 @@
       </p:sp>
       <p:pic>
         <p:nvPicPr>
-          <p:cNvPr id="31" name="Image 4" descr="p_lezen">    </p:cNvPr>
+          <p:cNvPr id="34" name="Image 4" descr="open book">    </p:cNvPr>
           <p:cNvPicPr>
             <a:picLocks noChangeAspect="1"/>
           </p:cNvPicPr>
@@ -31291,8 +31828,8 @@
         </p:blipFill>
         <p:spPr>
           <a:xfrm>
-            <a:off x="6487668" y="2578608"/>
-            <a:ext cx="731520" cy="731520"/>
+            <a:off x="6492240" y="2596896"/>
+            <a:ext cx="694944" cy="694944"/>
           </a:xfrm>
           <a:prstGeom prst="rect">
             <a:avLst/>
@@ -31301,14 +31838,14 @@
       </p:pic>
       <p:sp>
         <p:nvSpPr>
-          <p:cNvPr id="32" name="Text 24"/>
+          <p:cNvPr id="35" name="Text 27"/>
           <p:cNvSpPr txBox="1"/>
           <p:nvPr/>
         </p:nvSpPr>
         <p:spPr>
           <a:xfrm>
             <a:off x="7406640" y="2523744"/>
-            <a:ext cx="1645920" cy="841248"/>
+            <a:ext cx="1645920" cy="566928"/>
           </a:xfrm>
           <a:prstGeom prst="rect">
             <a:avLst/>
@@ -31340,7 +31877,36 @@
       </p:sp>
       <p:sp>
         <p:nvSpPr>
-          <p:cNvPr id="33" name="Text 25"/>
+          <p:cNvPr id="36" name="Shape 28"/>
+          <p:cNvSpPr/>
+          <p:nvPr/>
+        </p:nvSpPr>
+        <p:spPr>
+          <a:xfrm>
+            <a:off x="7434072" y="3127248"/>
+            <a:ext cx="1463040" cy="100584"/>
+          </a:xfrm>
+          <a:prstGeom prst="roundRect">
+            <a:avLst>
+              <a:gd name="adj" fmla="val 45455"/>
+            </a:avLst>
+          </a:prstGeom>
+          <a:solidFill>
+            <a:schemeClr val="accent3"/>
+          </a:solidFill>
+          <a:ln w="12700">
+            <a:solidFill>
+              <a:srgbClr val="FFFFFF">
+                <a:alpha val="0"/>
+              </a:srgbClr>
+            </a:solidFill>
+            <a:prstDash val="solid"/>
+          </a:ln>
+        </p:spPr>
+      </p:sp>
+      <p:sp>
+        <p:nvSpPr>
+          <p:cNvPr id="37" name="Text 29"/>
           <p:cNvSpPr txBox="1"/>
           <p:nvPr/>
         </p:nvSpPr>
@@ -31376,7 +31942,7 @@
       </p:sp>
       <p:sp>
         <p:nvSpPr>
-          <p:cNvPr id="34" name="tag"/>
+          <p:cNvPr id="38" name="tag"/>
           <p:cNvSpPr/>
           <p:nvPr/>
         </p:nvSpPr>
@@ -31416,7 +31982,7 @@
       </p:sp>
       <p:pic>
         <p:nvPicPr>
-          <p:cNvPr id="35" name="Image 5" descr="VolumeUp">    </p:cNvPr>
+          <p:cNvPr id="39" name="Image 5" descr="VolumeUp">    </p:cNvPr>
           <p:cNvPicPr>
             <a:picLocks noChangeAspect="1"/>
           </p:cNvPicPr>
@@ -31440,7 +32006,7 @@
       </p:pic>
       <p:sp>
         <p:nvSpPr>
-          <p:cNvPr id="36" name="Shape 27"/>
+          <p:cNvPr id="40" name="Shape 31"/>
           <p:cNvSpPr/>
           <p:nvPr/>
         </p:nvSpPr>
@@ -31467,7 +32033,7 @@
       </p:sp>
       <p:sp>
         <p:nvSpPr>
-          <p:cNvPr id="37" name="Text 28"/>
+          <p:cNvPr id="41" name="Text 32"/>
           <p:cNvSpPr txBox="1"/>
           <p:nvPr/>
         </p:nvSpPr>
@@ -31503,7 +32069,7 @@
       </p:sp>
       <p:sp>
         <p:nvSpPr>
-          <p:cNvPr id="38" name="Shape 29"/>
+          <p:cNvPr id="42" name="Shape 33"/>
           <p:cNvSpPr/>
           <p:nvPr/>
         </p:nvSpPr>
@@ -31527,7 +32093,7 @@
       </p:sp>
       <p:sp>
         <p:nvSpPr>
-          <p:cNvPr id="39" name="Shape 30"/>
+          <p:cNvPr id="43" name="Shape 34"/>
           <p:cNvSpPr/>
           <p:nvPr/>
         </p:nvSpPr>
@@ -31551,7 +32117,7 @@
       </p:sp>
       <p:sp>
         <p:nvSpPr>
-          <p:cNvPr id="40" name="Shape 31"/>
+          <p:cNvPr id="44" name="Shape 35"/>
           <p:cNvSpPr/>
           <p:nvPr/>
         </p:nvSpPr>
@@ -31578,7 +32144,7 @@
       </p:sp>
       <p:pic>
         <p:nvPicPr>
-          <p:cNvPr id="41" name="Image 6" descr="Chair">    </p:cNvPr>
+          <p:cNvPr id="45" name="Image 6" descr="chair">    </p:cNvPr>
           <p:cNvPicPr>
             <a:picLocks noChangeAspect="1"/>
           </p:cNvPicPr>
@@ -31592,8 +32158,8 @@
         </p:blipFill>
         <p:spPr>
           <a:xfrm>
-            <a:off x="1783080" y="3575304"/>
-            <a:ext cx="640080" cy="640080"/>
+            <a:off x="1737360" y="3547872"/>
+            <a:ext cx="694944" cy="694944"/>
           </a:xfrm>
           <a:prstGeom prst="rect">
             <a:avLst/>
@@ -31602,14 +32168,14 @@
       </p:pic>
       <p:sp>
         <p:nvSpPr>
-          <p:cNvPr id="42" name="Text 32"/>
+          <p:cNvPr id="46" name="Text 36"/>
           <p:cNvSpPr txBox="1"/>
           <p:nvPr/>
         </p:nvSpPr>
         <p:spPr>
           <a:xfrm>
             <a:off x="2651760" y="3474720"/>
-            <a:ext cx="1645920" cy="841248"/>
+            <a:ext cx="1645920" cy="566928"/>
           </a:xfrm>
           <a:prstGeom prst="rect">
             <a:avLst/>
@@ -31641,7 +32207,36 @@
       </p:sp>
       <p:sp>
         <p:nvSpPr>
-          <p:cNvPr id="43" name="Text 33"/>
+          <p:cNvPr id="47" name="Shape 37"/>
+          <p:cNvSpPr/>
+          <p:nvPr/>
+        </p:nvSpPr>
+        <p:spPr>
+          <a:xfrm>
+            <a:off x="2679192" y="4078224"/>
+            <a:ext cx="411480" cy="100584"/>
+          </a:xfrm>
+          <a:prstGeom prst="roundRect">
+            <a:avLst>
+              <a:gd name="adj" fmla="val 45455"/>
+            </a:avLst>
+          </a:prstGeom>
+          <a:solidFill>
+            <a:schemeClr val="accent4"/>
+          </a:solidFill>
+          <a:ln w="12700">
+            <a:solidFill>
+              <a:srgbClr val="FFFFFF">
+                <a:alpha val="0"/>
+              </a:srgbClr>
+            </a:solidFill>
+            <a:prstDash val="solid"/>
+          </a:ln>
+        </p:spPr>
+      </p:sp>
+      <p:sp>
+        <p:nvSpPr>
+          <p:cNvPr id="48" name="Text 38"/>
           <p:cNvSpPr txBox="1"/>
           <p:nvPr/>
         </p:nvSpPr>
@@ -31677,7 +32272,7 @@
       </p:sp>
       <p:sp>
         <p:nvSpPr>
-          <p:cNvPr id="44" name="tag"/>
+          <p:cNvPr id="49" name="tag"/>
           <p:cNvSpPr/>
           <p:nvPr/>
         </p:nvSpPr>
@@ -31717,7 +32312,7 @@
       </p:sp>
       <p:sp>
         <p:nvSpPr>
-          <p:cNvPr id="45" name="Shape 35"/>
+          <p:cNvPr id="50" name="Shape 40"/>
           <p:cNvSpPr/>
           <p:nvPr/>
         </p:nvSpPr>
@@ -31744,7 +32339,7 @@
       </p:sp>
       <p:pic>
         <p:nvPicPr>
-          <p:cNvPr id="46" name="Image 7" descr="Eye">    </p:cNvPr>
+          <p:cNvPr id="51" name="Image 7" descr="eyes">    </p:cNvPr>
           <p:cNvPicPr>
             <a:picLocks noChangeAspect="1"/>
           </p:cNvPicPr>
@@ -31758,8 +32353,8 @@
         </p:blipFill>
         <p:spPr>
           <a:xfrm>
-            <a:off x="6537960" y="3575304"/>
-            <a:ext cx="640080" cy="640080"/>
+            <a:off x="6492240" y="3547872"/>
+            <a:ext cx="694944" cy="694944"/>
           </a:xfrm>
           <a:prstGeom prst="rect">
             <a:avLst/>
@@ -31768,14 +32363,14 @@
       </p:pic>
       <p:sp>
         <p:nvSpPr>
-          <p:cNvPr id="47" name="Text 36"/>
+          <p:cNvPr id="52" name="Text 41"/>
           <p:cNvSpPr txBox="1"/>
           <p:nvPr/>
         </p:nvSpPr>
         <p:spPr>
           <a:xfrm>
             <a:off x="7406640" y="3474720"/>
-            <a:ext cx="1645920" cy="841248"/>
+            <a:ext cx="1645920" cy="566928"/>
           </a:xfrm>
           <a:prstGeom prst="rect">
             <a:avLst/>
@@ -31807,7 +32402,36 @@
       </p:sp>
       <p:sp>
         <p:nvSpPr>
-          <p:cNvPr id="48" name="Text 37"/>
+          <p:cNvPr id="53" name="Shape 42"/>
+          <p:cNvSpPr/>
+          <p:nvPr/>
+        </p:nvSpPr>
+        <p:spPr>
+          <a:xfrm>
+            <a:off x="7434072" y="4078224"/>
+            <a:ext cx="1463040" cy="100584"/>
+          </a:xfrm>
+          <a:prstGeom prst="roundRect">
+            <a:avLst>
+              <a:gd name="adj" fmla="val 45455"/>
+            </a:avLst>
+          </a:prstGeom>
+          <a:solidFill>
+            <a:schemeClr val="accent3"/>
+          </a:solidFill>
+          <a:ln w="12700">
+            <a:solidFill>
+              <a:srgbClr val="FFFFFF">
+                <a:alpha val="0"/>
+              </a:srgbClr>
+            </a:solidFill>
+            <a:prstDash val="solid"/>
+          </a:ln>
+        </p:spPr>
+      </p:sp>
+      <p:sp>
+        <p:nvSpPr>
+          <p:cNvPr id="54" name="Text 43"/>
           <p:cNvSpPr txBox="1"/>
           <p:nvPr/>
         </p:nvSpPr>
@@ -31843,7 +32467,7 @@
       </p:sp>
       <p:sp>
         <p:nvSpPr>
-          <p:cNvPr id="49" name="tag"/>
+          <p:cNvPr id="55" name="tag"/>
           <p:cNvSpPr/>
           <p:nvPr/>
         </p:nvSpPr>
@@ -31883,7 +32507,7 @@
       </p:sp>
       <p:pic>
         <p:nvPicPr>
-          <p:cNvPr id="50" name="Image 8" descr="VolumeUp">    </p:cNvPr>
+          <p:cNvPr id="56" name="Image 8" descr="VolumeUp">    </p:cNvPr>
           <p:cNvPicPr>
             <a:picLocks noChangeAspect="1"/>
           </p:cNvPicPr>
@@ -31907,7 +32531,7 @@
       </p:pic>
       <p:sp>
         <p:nvSpPr>
-          <p:cNvPr id="51" name="Shape 39"/>
+          <p:cNvPr id="57" name="Shape 45"/>
           <p:cNvSpPr/>
           <p:nvPr/>
         </p:nvSpPr>
@@ -31934,7 +32558,7 @@
       </p:sp>
       <p:sp>
         <p:nvSpPr>
-          <p:cNvPr id="52" name="Text 40"/>
+          <p:cNvPr id="58" name="Text 46"/>
           <p:cNvSpPr txBox="1"/>
           <p:nvPr/>
         </p:nvSpPr>
@@ -31970,7 +32594,7 @@
       </p:sp>
       <p:sp>
         <p:nvSpPr>
-          <p:cNvPr id="53" name="Shape 41"/>
+          <p:cNvPr id="59" name="Shape 47"/>
           <p:cNvSpPr/>
           <p:nvPr/>
         </p:nvSpPr>
@@ -31994,7 +32618,7 @@
       </p:sp>
       <p:sp>
         <p:nvSpPr>
-          <p:cNvPr id="54" name="Shape 42"/>
+          <p:cNvPr id="60" name="Shape 48"/>
           <p:cNvSpPr/>
           <p:nvPr/>
         </p:nvSpPr>
@@ -32018,7 +32642,7 @@
       </p:sp>
       <p:sp>
         <p:nvSpPr>
-          <p:cNvPr id="55" name="Shape 43"/>
+          <p:cNvPr id="61" name="Shape 49"/>
           <p:cNvSpPr/>
           <p:nvPr/>
         </p:nvSpPr>
@@ -32045,7 +32669,7 @@
       </p:sp>
       <p:pic>
         <p:nvPicPr>
-          <p:cNvPr id="56" name="Image 9" descr="p_koppel">    </p:cNvPr>
+          <p:cNvPr id="62" name="Image 9" descr="two hearts">    </p:cNvPr>
           <p:cNvPicPr>
             <a:picLocks noChangeAspect="1"/>
           </p:cNvPicPr>
@@ -32059,8 +32683,8 @@
         </p:blipFill>
         <p:spPr>
           <a:xfrm>
-            <a:off x="1732788" y="4480560"/>
-            <a:ext cx="731520" cy="731520"/>
+            <a:off x="1737360" y="4498848"/>
+            <a:ext cx="694944" cy="694944"/>
           </a:xfrm>
           <a:prstGeom prst="rect">
             <a:avLst/>
@@ -32069,14 +32693,14 @@
       </p:pic>
       <p:sp>
         <p:nvSpPr>
-          <p:cNvPr id="57" name="Text 44"/>
+          <p:cNvPr id="63" name="Text 50"/>
           <p:cNvSpPr txBox="1"/>
           <p:nvPr/>
         </p:nvSpPr>
         <p:spPr>
           <a:xfrm>
             <a:off x="2651760" y="4425696"/>
-            <a:ext cx="1645920" cy="841248"/>
+            <a:ext cx="1645920" cy="566928"/>
           </a:xfrm>
           <a:prstGeom prst="rect">
             <a:avLst/>
@@ -32108,7 +32732,36 @@
       </p:sp>
       <p:sp>
         <p:nvSpPr>
-          <p:cNvPr id="58" name="Text 45"/>
+          <p:cNvPr id="64" name="Shape 51"/>
+          <p:cNvSpPr/>
+          <p:nvPr/>
+        </p:nvSpPr>
+        <p:spPr>
+          <a:xfrm>
+            <a:off x="2679192" y="5029200"/>
+            <a:ext cx="411480" cy="100584"/>
+          </a:xfrm>
+          <a:prstGeom prst="roundRect">
+            <a:avLst>
+              <a:gd name="adj" fmla="val 45455"/>
+            </a:avLst>
+          </a:prstGeom>
+          <a:solidFill>
+            <a:schemeClr val="accent4"/>
+          </a:solidFill>
+          <a:ln w="12700">
+            <a:solidFill>
+              <a:srgbClr val="FFFFFF">
+                <a:alpha val="0"/>
+              </a:srgbClr>
+            </a:solidFill>
+            <a:prstDash val="solid"/>
+          </a:ln>
+        </p:spPr>
+      </p:sp>
+      <p:sp>
+        <p:nvSpPr>
+          <p:cNvPr id="65" name="Text 52"/>
           <p:cNvSpPr txBox="1"/>
           <p:nvPr/>
         </p:nvSpPr>
@@ -32144,7 +32797,7 @@
       </p:sp>
       <p:sp>
         <p:nvSpPr>
-          <p:cNvPr id="59" name="tag"/>
+          <p:cNvPr id="66" name="tag"/>
           <p:cNvSpPr/>
           <p:nvPr/>
         </p:nvSpPr>
@@ -32184,7 +32837,7 @@
       </p:sp>
       <p:sp>
         <p:nvSpPr>
-          <p:cNvPr id="60" name="Shape 47"/>
+          <p:cNvPr id="67" name="Shape 54"/>
           <p:cNvSpPr/>
           <p:nvPr/>
         </p:nvSpPr>
@@ -32211,7 +32864,7 @@
       </p:sp>
       <p:pic>
         <p:nvPicPr>
-          <p:cNvPr id="61" name="Image 10" descr="p_lopen">    </p:cNvPr>
+          <p:cNvPr id="68" name="Image 10" descr="person walking">    </p:cNvPr>
           <p:cNvPicPr>
             <a:picLocks noChangeAspect="1"/>
           </p:cNvPicPr>
@@ -32225,8 +32878,8 @@
         </p:blipFill>
         <p:spPr>
           <a:xfrm>
-            <a:off x="6487668" y="4480560"/>
-            <a:ext cx="731520" cy="731520"/>
+            <a:off x="6492240" y="4498848"/>
+            <a:ext cx="694944" cy="694944"/>
           </a:xfrm>
           <a:prstGeom prst="rect">
             <a:avLst/>
@@ -32235,14 +32888,14 @@
       </p:pic>
       <p:sp>
         <p:nvSpPr>
-          <p:cNvPr id="62" name="Text 48"/>
+          <p:cNvPr id="69" name="Text 55"/>
           <p:cNvSpPr txBox="1"/>
           <p:nvPr/>
         </p:nvSpPr>
         <p:spPr>
           <a:xfrm>
             <a:off x="7406640" y="4425696"/>
-            <a:ext cx="1645920" cy="841248"/>
+            <a:ext cx="1645920" cy="566928"/>
           </a:xfrm>
           <a:prstGeom prst="rect">
             <a:avLst/>
@@ -32274,7 +32927,36 @@
       </p:sp>
       <p:sp>
         <p:nvSpPr>
-          <p:cNvPr id="63" name="Text 49"/>
+          <p:cNvPr id="70" name="Shape 56"/>
+          <p:cNvSpPr/>
+          <p:nvPr/>
+        </p:nvSpPr>
+        <p:spPr>
+          <a:xfrm>
+            <a:off x="7434072" y="5029200"/>
+            <a:ext cx="1463040" cy="100584"/>
+          </a:xfrm>
+          <a:prstGeom prst="roundRect">
+            <a:avLst>
+              <a:gd name="adj" fmla="val 45455"/>
+            </a:avLst>
+          </a:prstGeom>
+          <a:solidFill>
+            <a:schemeClr val="accent3"/>
+          </a:solidFill>
+          <a:ln w="12700">
+            <a:solidFill>
+              <a:srgbClr val="FFFFFF">
+                <a:alpha val="0"/>
+              </a:srgbClr>
+            </a:solidFill>
+            <a:prstDash val="solid"/>
+          </a:ln>
+        </p:spPr>
+      </p:sp>
+      <p:sp>
+        <p:nvSpPr>
+          <p:cNvPr id="71" name="Text 57"/>
           <p:cNvSpPr txBox="1"/>
           <p:nvPr/>
         </p:nvSpPr>
@@ -32310,7 +32992,7 @@
       </p:sp>
       <p:sp>
         <p:nvSpPr>
-          <p:cNvPr id="64" name="tag"/>
+          <p:cNvPr id="72" name="tag"/>
           <p:cNvSpPr/>
           <p:nvPr/>
         </p:nvSpPr>
@@ -32350,7 +33032,7 @@
       </p:sp>
       <p:pic>
         <p:nvPicPr>
-          <p:cNvPr id="65" name="Image 11" descr="VolumeUp">    </p:cNvPr>
+          <p:cNvPr id="73" name="Image 11" descr="VolumeUp">    </p:cNvPr>
           <p:cNvPicPr>
             <a:picLocks noChangeAspect="1"/>
           </p:cNvPicPr>
@@ -32374,7 +33056,7 @@
       </p:pic>
       <p:sp>
         <p:nvSpPr>
-          <p:cNvPr id="66" name="Shape 51"/>
+          <p:cNvPr id="74" name="Shape 59"/>
           <p:cNvSpPr/>
           <p:nvPr/>
         </p:nvSpPr>
@@ -32401,7 +33083,7 @@
       </p:sp>
       <p:sp>
         <p:nvSpPr>
-          <p:cNvPr id="67" name="Text 52"/>
+          <p:cNvPr id="75" name="Text 60"/>
           <p:cNvSpPr txBox="1"/>
           <p:nvPr/>
         </p:nvSpPr>
@@ -32437,7 +33119,7 @@
       </p:sp>
       <p:sp>
         <p:nvSpPr>
-          <p:cNvPr id="68" name="Shape 53"/>
+          <p:cNvPr id="76" name="Shape 61"/>
           <p:cNvSpPr/>
           <p:nvPr/>
         </p:nvSpPr>
@@ -32461,7 +33143,7 @@
       </p:sp>
       <p:sp>
         <p:nvSpPr>
-          <p:cNvPr id="69" name="Shape 54"/>
+          <p:cNvPr id="77" name="Shape 62"/>
           <p:cNvSpPr/>
           <p:nvPr/>
         </p:nvSpPr>
@@ -32485,7 +33167,7 @@
       </p:sp>
       <p:sp>
         <p:nvSpPr>
-          <p:cNvPr id="70" name="Shape 55"/>
+          <p:cNvPr id="78" name="Shape 63"/>
           <p:cNvSpPr/>
           <p:nvPr/>
         </p:nvSpPr>
@@ -32512,7 +33194,7 @@
       </p:sp>
       <p:pic>
         <p:nvPicPr>
-          <p:cNvPr id="71" name="Image 12" descr="p_kus">    </p:cNvPr>
+          <p:cNvPr id="79" name="Image 12" descr="kiss mark">    </p:cNvPr>
           <p:cNvPicPr>
             <a:picLocks noChangeAspect="1"/>
           </p:cNvPicPr>
@@ -32526,8 +33208,8 @@
         </p:blipFill>
         <p:spPr>
           <a:xfrm>
-            <a:off x="1732788" y="5431536"/>
-            <a:ext cx="731520" cy="731520"/>
+            <a:off x="1737360" y="5449824"/>
+            <a:ext cx="694944" cy="694944"/>
           </a:xfrm>
           <a:prstGeom prst="rect">
             <a:avLst/>
@@ -32536,14 +33218,14 @@
       </p:pic>
       <p:sp>
         <p:nvSpPr>
-          <p:cNvPr id="72" name="Text 56"/>
+          <p:cNvPr id="80" name="Text 64"/>
           <p:cNvSpPr txBox="1"/>
           <p:nvPr/>
         </p:nvSpPr>
         <p:spPr>
           <a:xfrm>
             <a:off x="2651760" y="5376672"/>
-            <a:ext cx="1645920" cy="841248"/>
+            <a:ext cx="1645920" cy="566928"/>
           </a:xfrm>
           <a:prstGeom prst="rect">
             <a:avLst/>
@@ -32575,7 +33257,36 @@
       </p:sp>
       <p:sp>
         <p:nvSpPr>
-          <p:cNvPr id="73" name="Text 57"/>
+          <p:cNvPr id="81" name="Shape 65"/>
+          <p:cNvSpPr/>
+          <p:nvPr/>
+        </p:nvSpPr>
+        <p:spPr>
+          <a:xfrm>
+            <a:off x="2679192" y="5980176"/>
+            <a:ext cx="411480" cy="100584"/>
+          </a:xfrm>
+          <a:prstGeom prst="roundRect">
+            <a:avLst>
+              <a:gd name="adj" fmla="val 45455"/>
+            </a:avLst>
+          </a:prstGeom>
+          <a:solidFill>
+            <a:schemeClr val="accent4"/>
+          </a:solidFill>
+          <a:ln w="12700">
+            <a:solidFill>
+              <a:srgbClr val="FFFFFF">
+                <a:alpha val="0"/>
+              </a:srgbClr>
+            </a:solidFill>
+            <a:prstDash val="solid"/>
+          </a:ln>
+        </p:spPr>
+      </p:sp>
+      <p:sp>
+        <p:nvSpPr>
+          <p:cNvPr id="82" name="Text 66"/>
           <p:cNvSpPr txBox="1"/>
           <p:nvPr/>
         </p:nvSpPr>
@@ -32611,7 +33322,7 @@
       </p:sp>
       <p:sp>
         <p:nvSpPr>
-          <p:cNvPr id="74" name="tag"/>
+          <p:cNvPr id="83" name="tag"/>
           <p:cNvSpPr/>
           <p:nvPr/>
         </p:nvSpPr>
@@ -32651,7 +33362,7 @@
       </p:sp>
       <p:sp>
         <p:nvSpPr>
-          <p:cNvPr id="75" name="Shape 59"/>
+          <p:cNvPr id="84" name="Shape 68"/>
           <p:cNvSpPr/>
           <p:nvPr/>
         </p:nvSpPr>
@@ -32678,7 +33389,7 @@
       </p:sp>
       <p:pic>
         <p:nvPicPr>
-          <p:cNvPr id="76" name="Image 13" descr="p_vuur">    </p:cNvPr>
+          <p:cNvPr id="85" name="Image 13" descr="fire">    </p:cNvPr>
           <p:cNvPicPr>
             <a:picLocks noChangeAspect="1"/>
           </p:cNvPicPr>
@@ -32692,8 +33403,8 @@
         </p:blipFill>
         <p:spPr>
           <a:xfrm>
-            <a:off x="6487668" y="5431536"/>
-            <a:ext cx="731520" cy="731520"/>
+            <a:off x="6492240" y="5449824"/>
+            <a:ext cx="694944" cy="694944"/>
           </a:xfrm>
           <a:prstGeom prst="rect">
             <a:avLst/>
@@ -32702,14 +33413,14 @@
       </p:pic>
       <p:sp>
         <p:nvSpPr>
-          <p:cNvPr id="77" name="Text 60"/>
+          <p:cNvPr id="86" name="Text 69"/>
           <p:cNvSpPr txBox="1"/>
           <p:nvPr/>
         </p:nvSpPr>
         <p:spPr>
           <a:xfrm>
             <a:off x="7406640" y="5376672"/>
-            <a:ext cx="1645920" cy="841248"/>
+            <a:ext cx="1645920" cy="566928"/>
           </a:xfrm>
           <a:prstGeom prst="rect">
             <a:avLst/>
@@ -32741,7 +33452,36 @@
       </p:sp>
       <p:sp>
         <p:nvSpPr>
-          <p:cNvPr id="78" name="Text 61"/>
+          <p:cNvPr id="87" name="Shape 70"/>
+          <p:cNvSpPr/>
+          <p:nvPr/>
+        </p:nvSpPr>
+        <p:spPr>
+          <a:xfrm>
+            <a:off x="7434072" y="5980176"/>
+            <a:ext cx="1463040" cy="100584"/>
+          </a:xfrm>
+          <a:prstGeom prst="roundRect">
+            <a:avLst>
+              <a:gd name="adj" fmla="val 45455"/>
+            </a:avLst>
+          </a:prstGeom>
+          <a:solidFill>
+            <a:schemeClr val="accent3"/>
+          </a:solidFill>
+          <a:ln w="12700">
+            <a:solidFill>
+              <a:srgbClr val="FFFFFF">
+                <a:alpha val="0"/>
+              </a:srgbClr>
+            </a:solidFill>
+            <a:prstDash val="solid"/>
+          </a:ln>
+        </p:spPr>
+      </p:sp>
+      <p:sp>
+        <p:nvSpPr>
+          <p:cNvPr id="88" name="Text 71"/>
           <p:cNvSpPr txBox="1"/>
           <p:nvPr/>
         </p:nvSpPr>
@@ -32777,7 +33517,7 @@
       </p:sp>
       <p:sp>
         <p:nvSpPr>
-          <p:cNvPr id="79" name="tag"/>
+          <p:cNvPr id="89" name="tag"/>
           <p:cNvSpPr/>
           <p:nvPr/>
         </p:nvSpPr>
@@ -32817,7 +33557,7 @@
       </p:sp>
       <p:pic>
         <p:nvPicPr>
-          <p:cNvPr id="80" name="Image 14" descr="VolumeUp">    </p:cNvPr>
+          <p:cNvPr id="90" name="Image 14" descr="VolumeUp">    </p:cNvPr>
           <p:cNvPicPr>
             <a:picLocks noChangeAspect="1"/>
           </p:cNvPicPr>
@@ -38178,20 +38918,108 @@
         </p:nvSpPr>
         <p:spPr>
           <a:xfrm>
-            <a:off x="8412480" y="3977640"/>
-            <a:ext cx="3227832" cy="2286000"/>
+            <a:off x="8412480" y="3931920"/>
+            <a:ext cx="3227832" cy="566928"/>
           </a:xfrm>
           <a:prstGeom prst="roundRect">
             <a:avLst>
-              <a:gd name="adj" fmla="val 3200"/>
+              <a:gd name="adj" fmla="val 12903"/>
             </a:avLst>
           </a:prstGeom>
           <a:solidFill>
-            <a:schemeClr val="accent6">
-              <a:alpha val="7000"/>
-            </a:schemeClr>
+            <a:schemeClr val="bg2"/>
           </a:solidFill>
-          <a:ln w="12700">
+          <a:ln w="19050">
+            <a:solidFill>
+              <a:srgbClr val="17375E"/>
+            </a:solidFill>
+            <a:prstDash val="solid"/>
+          </a:ln>
+        </p:spPr>
+      </p:sp>
+      <p:sp>
+        <p:nvSpPr>
+          <p:cNvPr id="12" name="Text 7"/>
+          <p:cNvSpPr txBox="1"/>
+          <p:nvPr/>
+        </p:nvSpPr>
+        <p:spPr>
+          <a:xfrm>
+            <a:off x="8549640" y="3931920"/>
+            <a:ext cx="2633472" cy="566928"/>
+          </a:xfrm>
+          <a:prstGeom prst="rect">
+            <a:avLst/>
+          </a:prstGeom>
+          <a:noFill/>
+          <a:ln/>
+        </p:spPr>
+        <p:txBody>
+          <a:bodyPr wrap="square" lIns="0" tIns="0" rIns="0" bIns="0" rtlCol="0" anchor="ctr"/>
+          <a:lstStyle/>
+          <a:p>
+            <a:pPr algn="l" indent="0" marL="0">
+              <a:buNone/>
+            </a:pPr>
+            <a:r>
+              <a:rPr lang="en-US" sz="1800" b="1" dirty="0">
+                <a:solidFill>
+                  <a:schemeClr val="tx1"/>
+                </a:solidFill>
+                <a:latin typeface="+mj-lt" pitchFamily="34" charset="0"/>
+                <a:ea typeface="+mj-lt" pitchFamily="34" charset="-122"/>
+                <a:cs typeface="+mj-lt" pitchFamily="34" charset="-120"/>
+              </a:rPr>
+              <a:t>kat + en</a:t>
+            </a:r>
+            <a:endParaRPr lang="en-US" sz="1800" dirty="0"/>
+          </a:p>
+        </p:txBody>
+      </p:sp>
+      <p:sp>
+        <p:nvSpPr>
+          <p:cNvPr id="13" name="Shape 8"/>
+          <p:cNvSpPr/>
+          <p:nvPr/>
+        </p:nvSpPr>
+        <p:spPr>
+          <a:xfrm>
+            <a:off x="10026396" y="4517136"/>
+            <a:ext cx="914" cy="237744"/>
+          </a:xfrm>
+          <a:prstGeom prst="line">
+            <a:avLst/>
+          </a:prstGeom>
+          <a:noFill/>
+          <a:ln w="19050">
+            <a:solidFill>
+              <a:srgbClr val="4A5A70"/>
+            </a:solidFill>
+            <a:prstDash val="solid"/>
+            <a:tailEnd type="triangle"/>
+          </a:ln>
+        </p:spPr>
+      </p:sp>
+      <p:sp>
+        <p:nvSpPr>
+          <p:cNvPr id="14" name="Shape 9"/>
+          <p:cNvSpPr/>
+          <p:nvPr/>
+        </p:nvSpPr>
+        <p:spPr>
+          <a:xfrm>
+            <a:off x="8412480" y="4773168"/>
+            <a:ext cx="3227832" cy="566928"/>
+          </a:xfrm>
+          <a:prstGeom prst="roundRect">
+            <a:avLst>
+              <a:gd name="adj" fmla="val 12903"/>
+            </a:avLst>
+          </a:prstGeom>
+          <a:solidFill>
+            <a:srgbClr val="FBEDEB"/>
+          </a:solidFill>
+          <a:ln w="19050">
             <a:solidFill>
               <a:srgbClr val="B83227"/>
             </a:solidFill>
@@ -38199,9 +39027,59 @@
           </a:ln>
         </p:spPr>
       </p:sp>
+      <p:sp>
+        <p:nvSpPr>
+          <p:cNvPr id="15" name="Text 10"/>
+          <p:cNvSpPr txBox="1"/>
+          <p:nvPr/>
+        </p:nvSpPr>
+        <p:spPr>
+          <a:xfrm>
+            <a:off x="8549640" y="4773168"/>
+            <a:ext cx="2633472" cy="566928"/>
+          </a:xfrm>
+          <a:prstGeom prst="rect">
+            <a:avLst/>
+          </a:prstGeom>
+          <a:noFill/>
+          <a:ln/>
+        </p:spPr>
+        <p:txBody>
+          <a:bodyPr wrap="square" lIns="0" tIns="0" rIns="0" bIns="0" rtlCol="0" anchor="ctr"/>
+          <a:lstStyle/>
+          <a:p>
+            <a:pPr algn="l" indent="0" marL="0">
+              <a:buNone/>
+            </a:pPr>
+            <a:r>
+              <a:rPr lang="en-US" sz="1800" strike="sngStrike" dirty="0">
+                <a:solidFill>
+                  <a:schemeClr val="accent6"/>
+                </a:solidFill>
+                <a:latin typeface="+mj-lt" pitchFamily="34" charset="0"/>
+                <a:ea typeface="+mj-lt" pitchFamily="34" charset="-122"/>
+                <a:cs typeface="+mj-lt" pitchFamily="34" charset="-120"/>
+              </a:rPr>
+              <a:t>ka·ten</a:t>
+            </a:r>
+            <a:r>
+              <a:rPr lang="en-US" sz="1800" dirty="0">
+                <a:solidFill>
+                  <a:schemeClr val="tx1"/>
+                </a:solidFill>
+                <a:latin typeface="+mj-lt" pitchFamily="34" charset="0"/>
+                <a:ea typeface="+mj-lt" pitchFamily="34" charset="-122"/>
+                <a:cs typeface="+mj-lt" pitchFamily="34" charset="-120"/>
+              </a:rPr>
+              <a:t> = « kaa-ten »</a:t>
+            </a:r>
+            <a:endParaRPr lang="en-US" sz="1800" dirty="0"/>
+          </a:p>
+        </p:txBody>
+      </p:sp>
       <p:pic>
         <p:nvPicPr>
-          <p:cNvPr id="12" name="Image 1" descr="Times">    </p:cNvPr>
+          <p:cNvPr id="16" name="Image 1" descr="Times">    </p:cNvPr>
           <p:cNvPicPr>
             <a:picLocks noChangeAspect="1"/>
           </p:cNvPicPr>
@@ -38215,8 +39093,8 @@
         </p:blipFill>
         <p:spPr>
           <a:xfrm>
-            <a:off x="8595360" y="4114800"/>
-            <a:ext cx="365760" cy="365760"/>
+            <a:off x="11228832" y="4919472"/>
+            <a:ext cx="274320" cy="274320"/>
           </a:xfrm>
           <a:prstGeom prst="rect">
             <a:avLst/>
@@ -38225,77 +39103,118 @@
       </p:pic>
       <p:sp>
         <p:nvSpPr>
-          <p:cNvPr id="13" name="Text 7"/>
+          <p:cNvPr id="17" name="Shape 11"/>
+          <p:cNvSpPr/>
+          <p:nvPr/>
+        </p:nvSpPr>
+        <p:spPr>
+          <a:xfrm>
+            <a:off x="10026396" y="5358384"/>
+            <a:ext cx="914" cy="237744"/>
+          </a:xfrm>
+          <a:prstGeom prst="line">
+            <a:avLst/>
+          </a:prstGeom>
+          <a:noFill/>
+          <a:ln w="19050">
+            <a:solidFill>
+              <a:srgbClr val="4A5A70"/>
+            </a:solidFill>
+            <a:prstDash val="solid"/>
+            <a:tailEnd type="triangle"/>
+          </a:ln>
+        </p:spPr>
+      </p:sp>
+      <p:sp>
+        <p:nvSpPr>
+          <p:cNvPr id="18" name="Shape 12"/>
+          <p:cNvSpPr/>
+          <p:nvPr/>
+        </p:nvSpPr>
+        <p:spPr>
+          <a:xfrm>
+            <a:off x="8412480" y="5614416"/>
+            <a:ext cx="3227832" cy="566928"/>
+          </a:xfrm>
+          <a:prstGeom prst="roundRect">
+            <a:avLst>
+              <a:gd name="adj" fmla="val 12903"/>
+            </a:avLst>
+          </a:prstGeom>
+          <a:solidFill>
+            <a:srgbClr val="EDF6F0"/>
+          </a:solidFill>
+          <a:ln w="19050">
+            <a:solidFill>
+              <a:srgbClr val="B4236A"/>
+            </a:solidFill>
+            <a:prstDash val="solid"/>
+          </a:ln>
+        </p:spPr>
+      </p:sp>
+      <p:sp>
+        <p:nvSpPr>
+          <p:cNvPr id="19" name="Text 13"/>
           <p:cNvSpPr txBox="1"/>
           <p:nvPr/>
         </p:nvSpPr>
         <p:spPr>
           <a:xfrm>
-            <a:off x="8641080" y="4572000"/>
-            <a:ext cx="2834640" cy="1600200"/>
-          </a:xfrm>
-          <a:prstGeom prst="rect">
-            <a:avLst/>
-          </a:prstGeom>
-          <a:noFill/>
-          <a:ln/>
-        </p:spPr>
-        <p:txBody>
-          <a:bodyPr wrap="square" lIns="0" tIns="0" rIns="0" bIns="0" rtlCol="0" anchor="t"/>
+            <a:off x="8549640" y="5614416"/>
+            <a:ext cx="2633472" cy="566928"/>
+          </a:xfrm>
+          <a:prstGeom prst="rect">
+            <a:avLst/>
+          </a:prstGeom>
+          <a:noFill/>
+          <a:ln/>
+        </p:spPr>
+        <p:txBody>
+          <a:bodyPr wrap="square" lIns="0" tIns="0" rIns="0" bIns="0" rtlCol="0" anchor="ctr"/>
           <a:lstStyle/>
           <a:p>
             <a:pPr algn="l" indent="0" marL="0">
-              <a:spcAft>
-                <a:spcPts val="600"/>
-              </a:spcAft>
-              <a:buNone/>
-            </a:pPr>
-            <a:r>
-              <a:rPr lang="en-US" sz="1800" dirty="0">
+              <a:buNone/>
+            </a:pPr>
+            <a:r>
+              <a:rPr lang="en-US" sz="1800" b="1" dirty="0">
                 <a:solidFill>
                   <a:schemeClr val="tx1"/>
                 </a:solidFill>
-              </a:rPr>
-              <a:t>Sans doublement :</a:t>
+                <a:latin typeface="+mj-lt" pitchFamily="34" charset="0"/>
+                <a:ea typeface="+mj-lt" pitchFamily="34" charset="-122"/>
+                <a:cs typeface="+mj-lt" pitchFamily="34" charset="-120"/>
+              </a:rPr>
+              <a:t>kat·ten</a:t>
             </a:r>
             <a:endParaRPr lang="en-US" sz="1800" dirty="0"/>
           </a:p>
-          <a:p>
-            <a:pPr algn="l" indent="0" marL="0">
-              <a:spcAft>
-                <a:spcPts val="600"/>
-              </a:spcAft>
-              <a:buNone/>
-            </a:pPr>
-            <a:r>
-              <a:rPr lang="en-US" sz="1800" b="1" dirty="0">
-                <a:solidFill>
-                  <a:schemeClr val="tx1"/>
-                </a:solidFill>
-              </a:rPr>
-              <a:t>ka·ten</a:t>
-            </a:r>
-            <a:endParaRPr lang="en-US" sz="1800" dirty="0"/>
-          </a:p>
-          <a:p>
-            <a:pPr algn="l" indent="0" marL="0">
-              <a:spcAft>
-                <a:spcPts val="600"/>
-              </a:spcAft>
-              <a:buNone/>
-            </a:pPr>
-            <a:r>
-              <a:rPr lang="en-US" sz="1800" dirty="0">
-                <a:solidFill>
-                  <a:schemeClr val="tx1"/>
-                </a:solidFill>
-              </a:rPr>
-              <a:t>= « kaa-ten » (porte ouverte → son long)</a:t>
-            </a:r>
-            <a:endParaRPr lang="en-US" sz="1800" dirty="0"/>
-          </a:p>
-        </p:txBody>
-      </p:sp>
+        </p:txBody>
+      </p:sp>
+      <p:pic>
+        <p:nvPicPr>
+          <p:cNvPr id="20" name="Image 2" descr="Check">    </p:cNvPr>
+          <p:cNvPicPr>
+            <a:picLocks noChangeAspect="1"/>
+          </p:cNvPicPr>
+          <p:nvPr/>
+        </p:nvPicPr>
+        <p:blipFill>
+          <a:blip r:embed="rId3"/>
+          <a:stretch>
+            <a:fillRect/>
+          </a:stretch>
+        </p:blipFill>
+        <p:spPr>
+          <a:xfrm>
+            <a:off x="11228832" y="5760720"/>
+            <a:ext cx="274320" cy="274320"/>
+          </a:xfrm>
+          <a:prstGeom prst="rect">
+            <a:avLst/>
+          </a:prstGeom>
+        </p:spPr>
+      </p:pic>
       <p:sp>
         <p:nvSpPr>
           <p:cNvPr id="25" name="Slide Number Placeholder 0"/>
@@ -40083,20 +41002,108 @@
         </p:nvSpPr>
         <p:spPr>
           <a:xfrm>
-            <a:off x="8412480" y="3977640"/>
-            <a:ext cx="3227832" cy="2286000"/>
+            <a:off x="8412480" y="3931920"/>
+            <a:ext cx="3227832" cy="566928"/>
           </a:xfrm>
           <a:prstGeom prst="roundRect">
             <a:avLst>
-              <a:gd name="adj" fmla="val 3200"/>
+              <a:gd name="adj" fmla="val 12903"/>
             </a:avLst>
           </a:prstGeom>
           <a:solidFill>
-            <a:schemeClr val="accent6">
-              <a:alpha val="7000"/>
-            </a:schemeClr>
+            <a:schemeClr val="bg2"/>
           </a:solidFill>
-          <a:ln w="12700">
+          <a:ln w="19050">
+            <a:solidFill>
+              <a:srgbClr val="17375E"/>
+            </a:solidFill>
+            <a:prstDash val="solid"/>
+          </a:ln>
+        </p:spPr>
+      </p:sp>
+      <p:sp>
+        <p:nvSpPr>
+          <p:cNvPr id="12" name="Text 7"/>
+          <p:cNvSpPr txBox="1"/>
+          <p:nvPr/>
+        </p:nvSpPr>
+        <p:spPr>
+          <a:xfrm>
+            <a:off x="8549640" y="3931920"/>
+            <a:ext cx="2633472" cy="566928"/>
+          </a:xfrm>
+          <a:prstGeom prst="rect">
+            <a:avLst/>
+          </a:prstGeom>
+          <a:noFill/>
+          <a:ln/>
+        </p:spPr>
+        <p:txBody>
+          <a:bodyPr wrap="square" lIns="0" tIns="0" rIns="0" bIns="0" rtlCol="0" anchor="ctr"/>
+          <a:lstStyle/>
+          <a:p>
+            <a:pPr algn="l" indent="0" marL="0">
+              <a:buNone/>
+            </a:pPr>
+            <a:r>
+              <a:rPr lang="en-US" sz="1800" b="1" dirty="0">
+                <a:solidFill>
+                  <a:schemeClr val="tx1"/>
+                </a:solidFill>
+                <a:latin typeface="+mj-lt" pitchFamily="34" charset="0"/>
+                <a:ea typeface="+mj-lt" pitchFamily="34" charset="-122"/>
+                <a:cs typeface="+mj-lt" pitchFamily="34" charset="-120"/>
+              </a:rPr>
+              <a:t>raam + en</a:t>
+            </a:r>
+            <a:endParaRPr lang="en-US" sz="1800" dirty="0"/>
+          </a:p>
+        </p:txBody>
+      </p:sp>
+      <p:sp>
+        <p:nvSpPr>
+          <p:cNvPr id="13" name="Shape 8"/>
+          <p:cNvSpPr/>
+          <p:nvPr/>
+        </p:nvSpPr>
+        <p:spPr>
+          <a:xfrm>
+            <a:off x="10026396" y="4517136"/>
+            <a:ext cx="914" cy="237744"/>
+          </a:xfrm>
+          <a:prstGeom prst="line">
+            <a:avLst/>
+          </a:prstGeom>
+          <a:noFill/>
+          <a:ln w="19050">
+            <a:solidFill>
+              <a:srgbClr val="4A5A70"/>
+            </a:solidFill>
+            <a:prstDash val="solid"/>
+            <a:tailEnd type="triangle"/>
+          </a:ln>
+        </p:spPr>
+      </p:sp>
+      <p:sp>
+        <p:nvSpPr>
+          <p:cNvPr id="14" name="Shape 9"/>
+          <p:cNvSpPr/>
+          <p:nvPr/>
+        </p:nvSpPr>
+        <p:spPr>
+          <a:xfrm>
+            <a:off x="8412480" y="4773168"/>
+            <a:ext cx="3227832" cy="566928"/>
+          </a:xfrm>
+          <a:prstGeom prst="roundRect">
+            <a:avLst>
+              <a:gd name="adj" fmla="val 12903"/>
+            </a:avLst>
+          </a:prstGeom>
+          <a:solidFill>
+            <a:srgbClr val="FBEDEB"/>
+          </a:solidFill>
+          <a:ln w="19050">
             <a:solidFill>
               <a:srgbClr val="B83227"/>
             </a:solidFill>
@@ -40104,9 +41111,48 @@
           </a:ln>
         </p:spPr>
       </p:sp>
+      <p:sp>
+        <p:nvSpPr>
+          <p:cNvPr id="15" name="Text 10"/>
+          <p:cNvSpPr txBox="1"/>
+          <p:nvPr/>
+        </p:nvSpPr>
+        <p:spPr>
+          <a:xfrm>
+            <a:off x="8549640" y="4773168"/>
+            <a:ext cx="2633472" cy="566928"/>
+          </a:xfrm>
+          <a:prstGeom prst="rect">
+            <a:avLst/>
+          </a:prstGeom>
+          <a:noFill/>
+          <a:ln/>
+        </p:spPr>
+        <p:txBody>
+          <a:bodyPr wrap="square" lIns="0" tIns="0" rIns="0" bIns="0" rtlCol="0" anchor="ctr"/>
+          <a:lstStyle/>
+          <a:p>
+            <a:pPr algn="l" indent="0" marL="0">
+              <a:buNone/>
+            </a:pPr>
+            <a:r>
+              <a:rPr lang="en-US" sz="1800" strike="sngStrike" dirty="0">
+                <a:solidFill>
+                  <a:schemeClr val="accent6"/>
+                </a:solidFill>
+                <a:latin typeface="+mj-lt" pitchFamily="34" charset="0"/>
+                <a:ea typeface="+mj-lt" pitchFamily="34" charset="-122"/>
+                <a:cs typeface="+mj-lt" pitchFamily="34" charset="-120"/>
+              </a:rPr>
+              <a:t>raa·men</a:t>
+            </a:r>
+            <a:endParaRPr lang="en-US" sz="1800" dirty="0"/>
+          </a:p>
+        </p:txBody>
+      </p:sp>
       <p:pic>
         <p:nvPicPr>
-          <p:cNvPr id="12" name="Image 1" descr="Times">    </p:cNvPr>
+          <p:cNvPr id="16" name="Image 1" descr="Times">    </p:cNvPr>
           <p:cNvPicPr>
             <a:picLocks noChangeAspect="1"/>
           </p:cNvPicPr>
@@ -40120,8 +41166,8 @@
         </p:blipFill>
         <p:spPr>
           <a:xfrm>
-            <a:off x="8595360" y="4114800"/>
-            <a:ext cx="365760" cy="365760"/>
+            <a:off x="11228832" y="4919472"/>
+            <a:ext cx="274320" cy="274320"/>
           </a:xfrm>
           <a:prstGeom prst="rect">
             <a:avLst/>
@@ -40130,93 +41176,118 @@
       </p:pic>
       <p:sp>
         <p:nvSpPr>
-          <p:cNvPr id="13" name="Text 7"/>
+          <p:cNvPr id="17" name="Shape 11"/>
+          <p:cNvSpPr/>
+          <p:nvPr/>
+        </p:nvSpPr>
+        <p:spPr>
+          <a:xfrm>
+            <a:off x="10026396" y="5358384"/>
+            <a:ext cx="914" cy="237744"/>
+          </a:xfrm>
+          <a:prstGeom prst="line">
+            <a:avLst/>
+          </a:prstGeom>
+          <a:noFill/>
+          <a:ln w="19050">
+            <a:solidFill>
+              <a:srgbClr val="4A5A70"/>
+            </a:solidFill>
+            <a:prstDash val="solid"/>
+            <a:tailEnd type="triangle"/>
+          </a:ln>
+        </p:spPr>
+      </p:sp>
+      <p:sp>
+        <p:nvSpPr>
+          <p:cNvPr id="18" name="Shape 12"/>
+          <p:cNvSpPr/>
+          <p:nvPr/>
+        </p:nvSpPr>
+        <p:spPr>
+          <a:xfrm>
+            <a:off x="8412480" y="5614416"/>
+            <a:ext cx="3227832" cy="566928"/>
+          </a:xfrm>
+          <a:prstGeom prst="roundRect">
+            <a:avLst>
+              <a:gd name="adj" fmla="val 12903"/>
+            </a:avLst>
+          </a:prstGeom>
+          <a:solidFill>
+            <a:srgbClr val="EDF6F0"/>
+          </a:solidFill>
+          <a:ln w="19050">
+            <a:solidFill>
+              <a:srgbClr val="2E7D4F"/>
+            </a:solidFill>
+            <a:prstDash val="solid"/>
+          </a:ln>
+        </p:spPr>
+      </p:sp>
+      <p:sp>
+        <p:nvSpPr>
+          <p:cNvPr id="19" name="Text 13"/>
           <p:cNvSpPr txBox="1"/>
           <p:nvPr/>
         </p:nvSpPr>
         <p:spPr>
           <a:xfrm>
-            <a:off x="8641080" y="4572000"/>
-            <a:ext cx="2834640" cy="1600200"/>
-          </a:xfrm>
-          <a:prstGeom prst="rect">
-            <a:avLst/>
-          </a:prstGeom>
-          <a:noFill/>
-          <a:ln/>
-        </p:spPr>
-        <p:txBody>
-          <a:bodyPr wrap="square" lIns="0" tIns="0" rIns="0" bIns="0" rtlCol="0" anchor="t"/>
+            <a:off x="8549640" y="5614416"/>
+            <a:ext cx="2633472" cy="566928"/>
+          </a:xfrm>
+          <a:prstGeom prst="rect">
+            <a:avLst/>
+          </a:prstGeom>
+          <a:noFill/>
+          <a:ln/>
+        </p:spPr>
+        <p:txBody>
+          <a:bodyPr wrap="square" lIns="0" tIns="0" rIns="0" bIns="0" rtlCol="0" anchor="ctr"/>
           <a:lstStyle/>
           <a:p>
             <a:pPr algn="l" indent="0" marL="0">
-              <a:spcAft>
-                <a:spcPts val="600"/>
-              </a:spcAft>
-              <a:buNone/>
-            </a:pPr>
-            <a:r>
-              <a:rPr lang="en-US" sz="1800" dirty="0">
+              <a:buNone/>
+            </a:pPr>
+            <a:r>
+              <a:rPr lang="en-US" sz="1800" b="1" dirty="0">
                 <a:solidFill>
                   <a:schemeClr val="tx1"/>
                 </a:solidFill>
-              </a:rPr>
-              <a:t>On n’écrit jamais :</a:t>
+                <a:latin typeface="+mj-lt" pitchFamily="34" charset="0"/>
+                <a:ea typeface="+mj-lt" pitchFamily="34" charset="-122"/>
+                <a:cs typeface="+mj-lt" pitchFamily="34" charset="-120"/>
+              </a:rPr>
+              <a:t>ra·men</a:t>
             </a:r>
             <a:endParaRPr lang="en-US" sz="1800" dirty="0"/>
           </a:p>
-          <a:p>
-            <a:pPr algn="l" indent="0" marL="0">
-              <a:spcAft>
-                <a:spcPts val="600"/>
-              </a:spcAft>
-              <a:buNone/>
-            </a:pPr>
-            <a:r>
-              <a:rPr lang="en-US" sz="1800" b="1" strike="sngStrike" dirty="0">
-                <a:solidFill>
-                  <a:schemeClr val="accent6"/>
-                </a:solidFill>
-              </a:rPr>
-              <a:t>raamen</a:t>
-            </a:r>
-            <a:endParaRPr lang="en-US" sz="1800" dirty="0"/>
-          </a:p>
-          <a:p>
-            <a:pPr algn="l" indent="0" marL="0">
-              <a:spcAft>
-                <a:spcPts val="600"/>
-              </a:spcAft>
-              <a:buNone/>
-            </a:pPr>
-            <a:r>
-              <a:rPr lang="en-US" sz="1800" dirty="0">
-                <a:solidFill>
-                  <a:schemeClr val="tx1"/>
-                </a:solidFill>
-              </a:rPr>
-              <a:t>La porte est ouverte : un seul </a:t>
-            </a:r>
-            <a:r>
-              <a:rPr lang="en-US" sz="1800" i="1" dirty="0">
-                <a:solidFill>
-                  <a:schemeClr val="tx1"/>
-                </a:solidFill>
-              </a:rPr>
-              <a:t>a</a:t>
-            </a:r>
-            <a:r>
-              <a:rPr lang="en-US" sz="1800" dirty="0">
-                <a:solidFill>
-                  <a:schemeClr val="tx1"/>
-                </a:solidFill>
-              </a:rPr>
-              <a:t> suffit.</a:t>
-            </a:r>
-            <a:endParaRPr lang="en-US" sz="1800" dirty="0"/>
-          </a:p>
-        </p:txBody>
-      </p:sp>
+        </p:txBody>
+      </p:sp>
+      <p:pic>
+        <p:nvPicPr>
+          <p:cNvPr id="20" name="Image 2" descr="Check">    </p:cNvPr>
+          <p:cNvPicPr>
+            <a:picLocks noChangeAspect="1"/>
+          </p:cNvPicPr>
+          <p:nvPr/>
+        </p:nvPicPr>
+        <p:blipFill>
+          <a:blip r:embed="rId3"/>
+          <a:stretch>
+            <a:fillRect/>
+          </a:stretch>
+        </p:blipFill>
+        <p:spPr>
+          <a:xfrm>
+            <a:off x="11228832" y="5760720"/>
+            <a:ext cx="274320" cy="274320"/>
+          </a:xfrm>
+          <a:prstGeom prst="rect">
+            <a:avLst/>
+          </a:prstGeom>
+        </p:spPr>
+      </p:pic>
       <p:sp>
         <p:nvSpPr>
           <p:cNvPr id="25" name="Slide Number Placeholder 0"/>

</xml_diff>

<commit_message>
Néerlandais 1: PowerPoint decks for modules 6-10 and Dutch review fixes
Builds the five bloc 2 decks (Tweeklanken, Landen en talen, Formeel
of informeel, Zinnen verbinden, Een mail opstellen) and rebuilds
modules 1-5 (cover numbering out of 10, M5 ticket now closes bloc 1).
Applies the independent Dutch review of modules 6-10: ui glides to a
rounded u, -lijk with a schwa, Beste meneer / Geachte heer, the V2
statement for of, and consistent dates.

Co-Authored-By: Claude Opus 5.5 <noreply@anthropic.com>
Claude-Session: https://claude.ai/code/session_01GHo9GbchfMk8JhTz1kwo92
</commit_message>
<xml_diff>
--- a/neerlandais1/powerpoints/Module_1_Klanken.pptx
+++ b/neerlandais1/powerpoints/Module_1_Klanken.pptx
@@ -132,12 +132,12 @@
   <p:extLst>
     <p:ext uri="{521415D9-36F7-43E2-AB2F-B90AF26B5E84}">
       <p14:sectionLst xmlns:p14="http://schemas.microsoft.com/office/powerpoint/2010/main">
-        <p14:section name="Ouverture" id="{21158495-24cc-6afc-1804-52ea6ea5589a}">
+        <p14:section name="Ouverture" id="{9f0352a9-e928-7a11-9b51-3be6858021a0}">
           <p14:sldIdLst>
             <p14:sldId id="256"/>
           </p14:sldIdLst>
         </p14:section>
-        <p14:section name="Découvrir" id="{59026aba-ef8c-3daf-1d74-0e73483a8afa}">
+        <p14:section name="Découvrir" id="{86b0f6c1-905a-4331-0ae3-4c8c52b6cf8d}">
           <p14:sldIdLst>
             <p14:sldId id="257"/>
             <p14:sldId id="258"/>
@@ -145,7 +145,7 @@
             <p14:sldId id="260"/>
           </p14:sldIdLst>
         </p14:section>
-        <p14:section name="Comprendre" id="{c8f06942-d349-51f8-af0e-d0f280be5ac8}">
+        <p14:section name="Comprendre" id="{5ac276a7-fd8e-c22b-f6ce-e79aad62b7a8}">
           <p14:sldIdLst>
             <p14:sldId id="261"/>
             <p14:sldId id="262"/>
@@ -158,7 +158,7 @@
             <p14:sldId id="269"/>
           </p14:sldIdLst>
         </p14:section>
-        <p14:section name="JIJ NU ! — Oefeningen" id="{31755027-692d-2116-a3d9-3581e77ed940}">
+        <p14:section name="JIJ NU ! — Oefeningen" id="{c885c571-3a57-c32e-8bf5-1f486721cc0b}">
           <p14:sldIdLst>
             <p14:sldId id="270"/>
             <p14:sldId id="271"/>
@@ -173,7 +173,7 @@
             <p14:sldId id="280"/>
           </p14:sldIdLst>
         </p14:section>
-        <p14:section name="Clôture" id="{74554add-3d52-0642-504c-9389c6a2ab83}">
+        <p14:section name="Clôture" id="{dcb4facc-4c52-bfb9-e916-cbde895f4222}">
           <p14:sldIdLst>
             <p14:sldId id="281"/>
           </p14:sldIdLst>
@@ -3712,7 +3712,7 @@
         <p:spPr>
           <a:xfrm>
             <a:off x="548640" y="640080"/>
-            <a:ext cx="1876349" cy="384048"/>
+            <a:ext cx="2002231" cy="384048"/>
           </a:xfrm>
           <a:prstGeom prst="roundRect">
             <a:avLst>
@@ -3737,7 +3737,7 @@
                   <a:srgbClr val="FFFFFF"/>
                 </a:solidFill>
               </a:rPr>
-              <a:t>MODULE 1 / 5</a:t>
+              <a:t>MODULE 1 / 10</a:t>
             </a:r>
             <a:endParaRPr lang="en-US" sz="1400" dirty="0"/>
           </a:p>

</xml_diff>